<commit_message>
Implement COM-based sequential audio playback with timing
</commit_message>
<xml_diff>
--- a/research/audio_full_test.pptx
+++ b/research/audio_full_test.pptx
@@ -313,7 +313,7 @@
           <a:p>
             <a:fld id="{5BCAD085-E8A6-8845-BD4E-CB4CCA059FC4}" type="datetimeFigureOut">
               <a:rPr lang="en-US" smtClean="0"/>
-              <a:t>8/7/2026</a:t>
+              <a:t>8/8/2026</a:t>
             </a:fld>
             <a:endParaRPr lang="en-US"/>
           </a:p>
@@ -481,7 +481,7 @@
           <a:p>
             <a:fld id="{5BCAD085-E8A6-8845-BD4E-CB4CCA059FC4}" type="datetimeFigureOut">
               <a:rPr lang="en-US" smtClean="0"/>
-              <a:t>8/7/2026</a:t>
+              <a:t>8/8/2026</a:t>
             </a:fld>
             <a:endParaRPr lang="en-US"/>
           </a:p>
@@ -659,7 +659,7 @@
           <a:p>
             <a:fld id="{5BCAD085-E8A6-8845-BD4E-CB4CCA059FC4}" type="datetimeFigureOut">
               <a:rPr lang="en-US" smtClean="0"/>
-              <a:t>8/7/2026</a:t>
+              <a:t>8/8/2026</a:t>
             </a:fld>
             <a:endParaRPr lang="en-US"/>
           </a:p>
@@ -827,7 +827,7 @@
           <a:p>
             <a:fld id="{5BCAD085-E8A6-8845-BD4E-CB4CCA059FC4}" type="datetimeFigureOut">
               <a:rPr lang="en-US" smtClean="0"/>
-              <a:t>8/7/2026</a:t>
+              <a:t>8/8/2026</a:t>
             </a:fld>
             <a:endParaRPr lang="en-US"/>
           </a:p>
@@ -1072,7 +1072,7 @@
           <a:p>
             <a:fld id="{5BCAD085-E8A6-8845-BD4E-CB4CCA059FC4}" type="datetimeFigureOut">
               <a:rPr lang="en-US" smtClean="0"/>
-              <a:t>8/7/2026</a:t>
+              <a:t>8/8/2026</a:t>
             </a:fld>
             <a:endParaRPr lang="en-US"/>
           </a:p>
@@ -1357,7 +1357,7 @@
           <a:p>
             <a:fld id="{5BCAD085-E8A6-8845-BD4E-CB4CCA059FC4}" type="datetimeFigureOut">
               <a:rPr lang="en-US" smtClean="0"/>
-              <a:t>8/7/2026</a:t>
+              <a:t>8/8/2026</a:t>
             </a:fld>
             <a:endParaRPr lang="en-US"/>
           </a:p>
@@ -1776,7 +1776,7 @@
           <a:p>
             <a:fld id="{5BCAD085-E8A6-8845-BD4E-CB4CCA059FC4}" type="datetimeFigureOut">
               <a:rPr lang="en-US" smtClean="0"/>
-              <a:t>8/7/2026</a:t>
+              <a:t>8/8/2026</a:t>
             </a:fld>
             <a:endParaRPr lang="en-US"/>
           </a:p>
@@ -1893,7 +1893,7 @@
           <a:p>
             <a:fld id="{5BCAD085-E8A6-8845-BD4E-CB4CCA059FC4}" type="datetimeFigureOut">
               <a:rPr lang="en-US" smtClean="0"/>
-              <a:t>8/7/2026</a:t>
+              <a:t>8/8/2026</a:t>
             </a:fld>
             <a:endParaRPr lang="en-US"/>
           </a:p>
@@ -1988,7 +1988,7 @@
           <a:p>
             <a:fld id="{5BCAD085-E8A6-8845-BD4E-CB4CCA059FC4}" type="datetimeFigureOut">
               <a:rPr lang="en-US" smtClean="0"/>
-              <a:t>8/7/2026</a:t>
+              <a:t>8/8/2026</a:t>
             </a:fld>
             <a:endParaRPr lang="en-US"/>
           </a:p>
@@ -2263,7 +2263,7 @@
           <a:p>
             <a:fld id="{5BCAD085-E8A6-8845-BD4E-CB4CCA059FC4}" type="datetimeFigureOut">
               <a:rPr lang="en-US" smtClean="0"/>
-              <a:t>8/7/2026</a:t>
+              <a:t>8/8/2026</a:t>
             </a:fld>
             <a:endParaRPr lang="en-US"/>
           </a:p>
@@ -2515,7 +2515,7 @@
           <a:p>
             <a:fld id="{5BCAD085-E8A6-8845-BD4E-CB4CCA059FC4}" type="datetimeFigureOut">
               <a:rPr lang="en-US" smtClean="0"/>
-              <a:t>8/7/2026</a:t>
+              <a:t>8/8/2026</a:t>
             </a:fld>
             <a:endParaRPr lang="en-US"/>
           </a:p>
@@ -2726,7 +2726,7 @@
           <a:p>
             <a:fld id="{5BCAD085-E8A6-8845-BD4E-CB4CCA059FC4}" type="datetimeFigureOut">
               <a:rPr lang="en-US" smtClean="0"/>
-              <a:t>8/7/2026</a:t>
+              <a:t>8/8/2026</a:t>
             </a:fld>
             <a:endParaRPr lang="en-US"/>
           </a:p>
@@ -3609,7 +3609,7 @@
             <a:hlinkClick r:id="" action="ppaction://media"/>
             <a:extLst>
               <a:ext uri="{FF2B5EF4-FFF2-40B4-BE49-F238E27FC236}">
-                <a16:creationId xmlns:a16="http://schemas.microsoft.com/office/drawing/2014/main" id="{FB79B03F-2D65-A810-E69C-71C0E0DAB4CA}"/>
+                <a16:creationId xmlns:a16="http://schemas.microsoft.com/office/drawing/2014/main" id="{DAAFA269-7762-3CA6-9E69-7893A55D32F7}"/>
               </a:ext>
             </a:extLst>
           </p:cNvPr>
@@ -3647,7 +3647,7 @@
             <a:hlinkClick r:id="" action="ppaction://media"/>
             <a:extLst>
               <a:ext uri="{FF2B5EF4-FFF2-40B4-BE49-F238E27FC236}">
-                <a16:creationId xmlns:a16="http://schemas.microsoft.com/office/drawing/2014/main" id="{727DA98C-DE1D-41C8-400A-0F9E584C664E}"/>
+                <a16:creationId xmlns:a16="http://schemas.microsoft.com/office/drawing/2014/main" id="{0F1F6335-756E-EAF2-2BBD-5FF3BE262B99}"/>
               </a:ext>
             </a:extLst>
           </p:cNvPr>
@@ -3685,7 +3685,7 @@
             <a:hlinkClick r:id="" action="ppaction://media"/>
             <a:extLst>
               <a:ext uri="{FF2B5EF4-FFF2-40B4-BE49-F238E27FC236}">
-                <a16:creationId xmlns:a16="http://schemas.microsoft.com/office/drawing/2014/main" id="{D35DA1D7-1AF4-6FFA-BA05-1C2846B1185E}"/>
+                <a16:creationId xmlns:a16="http://schemas.microsoft.com/office/drawing/2014/main" id="{14EFDA69-9BAF-E1EB-29DD-028643EE977C}"/>
               </a:ext>
             </a:extLst>
           </p:cNvPr>
@@ -3728,7 +3728,117 @@
         <p:cTn id="1" dur="indefinite" restart="never" nodeType="tmRoot">
           <p:childTnLst>
             <p:seq concurrent="1" nextAc="seek">
-              <p:cTn id="2" restart="whenNotActive" fill="hold" evtFilter="cancelBubble" nodeType="interactiveSeq">
+              <p:cTn id="2" dur="indefinite" nodeType="mainSeq">
+                <p:childTnLst>
+                  <p:par>
+                    <p:cTn id="3" fill="hold">
+                      <p:stCondLst>
+                        <p:cond delay="indefinite"/>
+                        <p:cond evt="onBegin" delay="0">
+                          <p:tn val="2"/>
+                        </p:cond>
+                      </p:stCondLst>
+                      <p:childTnLst>
+                        <p:par>
+                          <p:cTn id="4" fill="hold">
+                            <p:stCondLst>
+                              <p:cond delay="0"/>
+                            </p:stCondLst>
+                            <p:childTnLst>
+                              <p:par>
+                                <p:cTn id="5" presetID="1" presetClass="mediacall" presetSubtype="0" fill="hold" nodeType="afterEffect">
+                                  <p:stCondLst>
+                                    <p:cond delay="300"/>
+                                  </p:stCondLst>
+                                  <p:childTnLst>
+                                    <p:cmd type="call" cmd="playFrom(0.0)">
+                                      <p:cBhvr>
+                                        <p:cTn id="6" dur="914" fill="hold"/>
+                                        <p:tgtEl>
+                                          <p:spTgt spid="4"/>
+                                        </p:tgtEl>
+                                      </p:cBhvr>
+                                    </p:cmd>
+                                  </p:childTnLst>
+                                </p:cTn>
+                              </p:par>
+                            </p:childTnLst>
+                          </p:cTn>
+                        </p:par>
+                        <p:par>
+                          <p:cTn id="7" fill="hold">
+                            <p:stCondLst>
+                              <p:cond delay="1240"/>
+                            </p:stCondLst>
+                            <p:childTnLst>
+                              <p:par>
+                                <p:cTn id="8" presetID="1" presetClass="mediacall" presetSubtype="0" fill="hold" nodeType="afterEffect">
+                                  <p:stCondLst>
+                                    <p:cond delay="300"/>
+                                  </p:stCondLst>
+                                  <p:childTnLst>
+                                    <p:cmd type="call" cmd="playFrom(0.0)">
+                                      <p:cBhvr>
+                                        <p:cTn id="9" dur="914" fill="hold"/>
+                                        <p:tgtEl>
+                                          <p:spTgt spid="6"/>
+                                        </p:tgtEl>
+                                      </p:cBhvr>
+                                    </p:cmd>
+                                  </p:childTnLst>
+                                </p:cTn>
+                              </p:par>
+                            </p:childTnLst>
+                          </p:cTn>
+                        </p:par>
+                        <p:par>
+                          <p:cTn id="10" fill="hold">
+                            <p:stCondLst>
+                              <p:cond delay="2480"/>
+                            </p:stCondLst>
+                            <p:childTnLst>
+                              <p:par>
+                                <p:cTn id="11" presetID="1" presetClass="mediacall" presetSubtype="0" fill="hold" nodeType="afterEffect">
+                                  <p:stCondLst>
+                                    <p:cond delay="300"/>
+                                  </p:stCondLst>
+                                  <p:childTnLst>
+                                    <p:cmd type="call" cmd="playFrom(0.0)">
+                                      <p:cBhvr>
+                                        <p:cTn id="12" dur="3474" fill="hold"/>
+                                        <p:tgtEl>
+                                          <p:spTgt spid="9"/>
+                                        </p:tgtEl>
+                                      </p:cBhvr>
+                                    </p:cmd>
+                                  </p:childTnLst>
+                                </p:cTn>
+                              </p:par>
+                            </p:childTnLst>
+                          </p:cTn>
+                        </p:par>
+                      </p:childTnLst>
+                    </p:cTn>
+                  </p:par>
+                </p:childTnLst>
+              </p:cTn>
+              <p:prevCondLst>
+                <p:cond evt="onPrev" delay="0">
+                  <p:tgtEl>
+                    <p:sldTgt/>
+                  </p:tgtEl>
+                </p:cond>
+              </p:prevCondLst>
+              <p:nextCondLst>
+                <p:cond evt="onNext" delay="0">
+                  <p:tgtEl>
+                    <p:sldTgt/>
+                  </p:tgtEl>
+                </p:cond>
+              </p:nextCondLst>
+            </p:seq>
+            <p:seq concurrent="1" nextAc="seek">
+              <p:cTn id="13" restart="whenNotActive" fill="hold" evtFilter="cancelBubble" nodeType="interactiveSeq">
                 <p:stCondLst>
                   <p:cond evt="onClick" delay="0">
                     <p:tgtEl>
@@ -3741,26 +3851,26 @@
                 </p:endSync>
                 <p:childTnLst>
                   <p:par>
-                    <p:cTn id="3" fill="hold">
+                    <p:cTn id="14" fill="hold">
                       <p:stCondLst>
                         <p:cond delay="0"/>
                       </p:stCondLst>
                       <p:childTnLst>
                         <p:par>
-                          <p:cTn id="4" fill="hold">
+                          <p:cTn id="15" fill="hold">
                             <p:stCondLst>
                               <p:cond delay="0"/>
                             </p:stCondLst>
                             <p:childTnLst>
                               <p:par>
-                                <p:cTn id="5" presetID="1" presetClass="mediacall" presetSubtype="0" fill="hold" nodeType="clickEffect">
+                                <p:cTn id="16" presetID="1" presetClass="mediacall" presetSubtype="0" fill="hold" nodeType="clickEffect">
                                   <p:stCondLst>
                                     <p:cond delay="0"/>
                                   </p:stCondLst>
                                   <p:childTnLst>
                                     <p:cmd type="call" cmd="playFrom(0.0)">
                                       <p:cBhvr>
-                                        <p:cTn id="6" dur="940" fill="hold"/>
+                                        <p:cTn id="17" dur="940" fill="hold"/>
                                         <p:tgtEl>
                                           <p:spTgt spid="4"/>
                                         </p:tgtEl>
@@ -3787,7 +3897,7 @@
             </p:seq>
             <p:audio>
               <p:cMediaNode vol="80000">
-                <p:cTn id="7" fill="hold" display="0">
+                <p:cTn id="18" fill="hold" display="0">
                   <p:stCondLst>
                     <p:cond delay="indefinite"/>
                   </p:stCondLst>
@@ -3805,7 +3915,7 @@
               </p:cMediaNode>
             </p:audio>
             <p:seq concurrent="1" nextAc="seek">
-              <p:cTn id="8" restart="whenNotActive" fill="hold" evtFilter="cancelBubble" nodeType="interactiveSeq">
+              <p:cTn id="19" restart="whenNotActive" fill="hold" evtFilter="cancelBubble" nodeType="interactiveSeq">
                 <p:stCondLst>
                   <p:cond evt="onClick" delay="0">
                     <p:tgtEl>
@@ -3818,26 +3928,26 @@
                 </p:endSync>
                 <p:childTnLst>
                   <p:par>
-                    <p:cTn id="9" fill="hold">
+                    <p:cTn id="20" fill="hold">
                       <p:stCondLst>
                         <p:cond delay="0"/>
                       </p:stCondLst>
                       <p:childTnLst>
                         <p:par>
-                          <p:cTn id="10" fill="hold">
+                          <p:cTn id="21" fill="hold">
                             <p:stCondLst>
                               <p:cond delay="0"/>
                             </p:stCondLst>
                             <p:childTnLst>
                               <p:par>
-                                <p:cTn id="11" presetID="1" presetClass="mediacall" presetSubtype="0" fill="hold" nodeType="clickEffect">
+                                <p:cTn id="22" presetID="1" presetClass="mediacall" presetSubtype="0" fill="hold" nodeType="clickEffect">
                                   <p:stCondLst>
                                     <p:cond delay="0"/>
                                   </p:stCondLst>
                                   <p:childTnLst>
                                     <p:cmd type="call" cmd="playFrom(0.0)">
                                       <p:cBhvr>
-                                        <p:cTn id="12" dur="940" fill="hold"/>
+                                        <p:cTn id="23" dur="940" fill="hold"/>
                                         <p:tgtEl>
                                           <p:spTgt spid="6"/>
                                         </p:tgtEl>
@@ -3864,7 +3974,7 @@
             </p:seq>
             <p:audio>
               <p:cMediaNode vol="80000">
-                <p:cTn id="13" fill="hold" display="0">
+                <p:cTn id="24" fill="hold" display="0">
                   <p:stCondLst>
                     <p:cond delay="indefinite"/>
                   </p:stCondLst>
@@ -3882,7 +3992,7 @@
               </p:cMediaNode>
             </p:audio>
             <p:seq concurrent="1" nextAc="seek">
-              <p:cTn id="14" restart="whenNotActive" fill="hold" evtFilter="cancelBubble" nodeType="interactiveSeq">
+              <p:cTn id="25" restart="whenNotActive" fill="hold" evtFilter="cancelBubble" nodeType="interactiveSeq">
                 <p:stCondLst>
                   <p:cond evt="onClick" delay="0">
                     <p:tgtEl>
@@ -3895,26 +4005,26 @@
                 </p:endSync>
                 <p:childTnLst>
                   <p:par>
-                    <p:cTn id="15" fill="hold">
+                    <p:cTn id="26" fill="hold">
                       <p:stCondLst>
                         <p:cond delay="0"/>
                       </p:stCondLst>
                       <p:childTnLst>
                         <p:par>
-                          <p:cTn id="16" fill="hold">
+                          <p:cTn id="27" fill="hold">
                             <p:stCondLst>
                               <p:cond delay="0"/>
                             </p:stCondLst>
                             <p:childTnLst>
                               <p:par>
-                                <p:cTn id="17" presetID="1" presetClass="mediacall" presetSubtype="0" fill="hold" nodeType="clickEffect">
+                                <p:cTn id="28" presetID="1" presetClass="mediacall" presetSubtype="0" fill="hold" nodeType="clickEffect">
                                   <p:stCondLst>
                                     <p:cond delay="0"/>
                                   </p:stCondLst>
                                   <p:childTnLst>
                                     <p:cmd type="call" cmd="playFrom(0.0)">
                                       <p:cBhvr>
-                                        <p:cTn id="18" dur="3500" fill="hold"/>
+                                        <p:cTn id="29" dur="3500" fill="hold"/>
                                         <p:tgtEl>
                                           <p:spTgt spid="9"/>
                                         </p:tgtEl>
@@ -3941,7 +4051,7 @@
             </p:seq>
             <p:audio>
               <p:cMediaNode vol="80000">
-                <p:cTn id="19" fill="hold" display="0">
+                <p:cTn id="30" fill="hold" display="0">
                   <p:stCondLst>
                     <p:cond delay="indefinite"/>
                   </p:stCondLst>
@@ -4496,7 +4606,7 @@
             <a:hlinkClick r:id="" action="ppaction://media"/>
             <a:extLst>
               <a:ext uri="{FF2B5EF4-FFF2-40B4-BE49-F238E27FC236}">
-                <a16:creationId xmlns:a16="http://schemas.microsoft.com/office/drawing/2014/main" id="{3BB5DC64-D18A-F414-5F61-E782E8657A52}"/>
+                <a16:creationId xmlns:a16="http://schemas.microsoft.com/office/drawing/2014/main" id="{4D7FD7B9-7B69-2101-0B84-67FE66C7AC6E}"/>
               </a:ext>
             </a:extLst>
           </p:cNvPr>
@@ -4539,7 +4649,65 @@
         <p:cTn id="1" dur="indefinite" restart="never" nodeType="tmRoot">
           <p:childTnLst>
             <p:seq concurrent="1" nextAc="seek">
-              <p:cTn id="2" restart="whenNotActive" fill="hold" evtFilter="cancelBubble" nodeType="interactiveSeq">
+              <p:cTn id="2" dur="indefinite" nodeType="mainSeq">
+                <p:childTnLst>
+                  <p:par>
+                    <p:cTn id="3" fill="hold">
+                      <p:stCondLst>
+                        <p:cond delay="indefinite"/>
+                        <p:cond evt="onBegin" delay="0">
+                          <p:tn val="2"/>
+                        </p:cond>
+                      </p:stCondLst>
+                      <p:childTnLst>
+                        <p:par>
+                          <p:cTn id="4" fill="hold">
+                            <p:stCondLst>
+                              <p:cond delay="0"/>
+                            </p:stCondLst>
+                            <p:childTnLst>
+                              <p:par>
+                                <p:cTn id="5" presetID="1" presetClass="mediacall" presetSubtype="0" fill="hold" nodeType="afterEffect">
+                                  <p:stCondLst>
+                                    <p:cond delay="300"/>
+                                  </p:stCondLst>
+                                  <p:childTnLst>
+                                    <p:cmd type="call" cmd="playFrom(0.0)">
+                                      <p:cBhvr>
+                                        <p:cTn id="6" dur="4362" fill="hold"/>
+                                        <p:tgtEl>
+                                          <p:spTgt spid="6"/>
+                                        </p:tgtEl>
+                                      </p:cBhvr>
+                                    </p:cmd>
+                                  </p:childTnLst>
+                                </p:cTn>
+                              </p:par>
+                            </p:childTnLst>
+                          </p:cTn>
+                        </p:par>
+                      </p:childTnLst>
+                    </p:cTn>
+                  </p:par>
+                </p:childTnLst>
+              </p:cTn>
+              <p:prevCondLst>
+                <p:cond evt="onPrev" delay="0">
+                  <p:tgtEl>
+                    <p:sldTgt/>
+                  </p:tgtEl>
+                </p:cond>
+              </p:prevCondLst>
+              <p:nextCondLst>
+                <p:cond evt="onNext" delay="0">
+                  <p:tgtEl>
+                    <p:sldTgt/>
+                  </p:tgtEl>
+                </p:cond>
+              </p:nextCondLst>
+            </p:seq>
+            <p:seq concurrent="1" nextAc="seek">
+              <p:cTn id="7" restart="whenNotActive" fill="hold" evtFilter="cancelBubble" nodeType="interactiveSeq">
                 <p:stCondLst>
                   <p:cond evt="onClick" delay="0">
                     <p:tgtEl>
@@ -4552,26 +4720,26 @@
                 </p:endSync>
                 <p:childTnLst>
                   <p:par>
-                    <p:cTn id="3" fill="hold">
+                    <p:cTn id="8" fill="hold">
                       <p:stCondLst>
                         <p:cond delay="0"/>
                       </p:stCondLst>
                       <p:childTnLst>
                         <p:par>
-                          <p:cTn id="4" fill="hold">
+                          <p:cTn id="9" fill="hold">
                             <p:stCondLst>
                               <p:cond delay="0"/>
                             </p:stCondLst>
                             <p:childTnLst>
                               <p:par>
-                                <p:cTn id="5" presetID="1" presetClass="mediacall" presetSubtype="0" fill="hold" nodeType="clickEffect">
+                                <p:cTn id="10" presetID="1" presetClass="mediacall" presetSubtype="0" fill="hold" nodeType="clickEffect">
                                   <p:stCondLst>
                                     <p:cond delay="0"/>
                                   </p:stCondLst>
                                   <p:childTnLst>
                                     <p:cmd type="call" cmd="playFrom(0.0)">
                                       <p:cBhvr>
-                                        <p:cTn id="6" dur="4388" fill="hold"/>
+                                        <p:cTn id="11" dur="4388" fill="hold"/>
                                         <p:tgtEl>
                                           <p:spTgt spid="6"/>
                                         </p:tgtEl>
@@ -4598,7 +4766,7 @@
             </p:seq>
             <p:audio>
               <p:cMediaNode vol="80000">
-                <p:cTn id="7" fill="hold" display="0">
+                <p:cTn id="12" fill="hold" display="0">
                   <p:stCondLst>
                     <p:cond delay="indefinite"/>
                   </p:stCondLst>
@@ -5201,7 +5369,7 @@
             <a:hlinkClick r:id="" action="ppaction://media"/>
             <a:extLst>
               <a:ext uri="{FF2B5EF4-FFF2-40B4-BE49-F238E27FC236}">
-                <a16:creationId xmlns:a16="http://schemas.microsoft.com/office/drawing/2014/main" id="{01D13A20-182A-0DF1-153F-AC74248EB147}"/>
+                <a16:creationId xmlns:a16="http://schemas.microsoft.com/office/drawing/2014/main" id="{CD0EB34D-2A46-5B75-684F-16DFB667A4F2}"/>
               </a:ext>
             </a:extLst>
           </p:cNvPr>
@@ -5244,7 +5412,65 @@
         <p:cTn id="1" dur="indefinite" restart="never" nodeType="tmRoot">
           <p:childTnLst>
             <p:seq concurrent="1" nextAc="seek">
-              <p:cTn id="2" restart="whenNotActive" fill="hold" evtFilter="cancelBubble" nodeType="interactiveSeq">
+              <p:cTn id="2" dur="indefinite" nodeType="mainSeq">
+                <p:childTnLst>
+                  <p:par>
+                    <p:cTn id="3" fill="hold">
+                      <p:stCondLst>
+                        <p:cond delay="indefinite"/>
+                        <p:cond evt="onBegin" delay="0">
+                          <p:tn val="2"/>
+                        </p:cond>
+                      </p:stCondLst>
+                      <p:childTnLst>
+                        <p:par>
+                          <p:cTn id="4" fill="hold">
+                            <p:stCondLst>
+                              <p:cond delay="0"/>
+                            </p:stCondLst>
+                            <p:childTnLst>
+                              <p:par>
+                                <p:cTn id="5" presetID="1" presetClass="mediacall" presetSubtype="0" fill="hold" nodeType="afterEffect">
+                                  <p:stCondLst>
+                                    <p:cond delay="300"/>
+                                  </p:stCondLst>
+                                  <p:childTnLst>
+                                    <p:cmd type="call" cmd="playFrom(0.0)">
+                                      <p:cBhvr>
+                                        <p:cTn id="6" dur="4624" fill="hold"/>
+                                        <p:tgtEl>
+                                          <p:spTgt spid="6"/>
+                                        </p:tgtEl>
+                                      </p:cBhvr>
+                                    </p:cmd>
+                                  </p:childTnLst>
+                                </p:cTn>
+                              </p:par>
+                            </p:childTnLst>
+                          </p:cTn>
+                        </p:par>
+                      </p:childTnLst>
+                    </p:cTn>
+                  </p:par>
+                </p:childTnLst>
+              </p:cTn>
+              <p:prevCondLst>
+                <p:cond evt="onPrev" delay="0">
+                  <p:tgtEl>
+                    <p:sldTgt/>
+                  </p:tgtEl>
+                </p:cond>
+              </p:prevCondLst>
+              <p:nextCondLst>
+                <p:cond evt="onNext" delay="0">
+                  <p:tgtEl>
+                    <p:sldTgt/>
+                  </p:tgtEl>
+                </p:cond>
+              </p:nextCondLst>
+            </p:seq>
+            <p:seq concurrent="1" nextAc="seek">
+              <p:cTn id="7" restart="whenNotActive" fill="hold" evtFilter="cancelBubble" nodeType="interactiveSeq">
                 <p:stCondLst>
                   <p:cond evt="onClick" delay="0">
                     <p:tgtEl>
@@ -5257,26 +5483,26 @@
                 </p:endSync>
                 <p:childTnLst>
                   <p:par>
-                    <p:cTn id="3" fill="hold">
+                    <p:cTn id="8" fill="hold">
                       <p:stCondLst>
                         <p:cond delay="0"/>
                       </p:stCondLst>
                       <p:childTnLst>
                         <p:par>
-                          <p:cTn id="4" fill="hold">
+                          <p:cTn id="9" fill="hold">
                             <p:stCondLst>
                               <p:cond delay="0"/>
                             </p:stCondLst>
                             <p:childTnLst>
                               <p:par>
-                                <p:cTn id="5" presetID="1" presetClass="mediacall" presetSubtype="0" fill="hold" nodeType="clickEffect">
+                                <p:cTn id="10" presetID="1" presetClass="mediacall" presetSubtype="0" fill="hold" nodeType="clickEffect">
                                   <p:stCondLst>
                                     <p:cond delay="0"/>
                                   </p:stCondLst>
                                   <p:childTnLst>
                                     <p:cmd type="call" cmd="playFrom(0.0)">
                                       <p:cBhvr>
-                                        <p:cTn id="6" dur="4649" fill="hold"/>
+                                        <p:cTn id="11" dur="4649" fill="hold"/>
                                         <p:tgtEl>
                                           <p:spTgt spid="6"/>
                                         </p:tgtEl>
@@ -5303,7 +5529,7 @@
             </p:seq>
             <p:audio>
               <p:cMediaNode vol="80000">
-                <p:cTn id="7" fill="hold" display="0">
+                <p:cTn id="12" fill="hold" display="0">
                   <p:stCondLst>
                     <p:cond delay="indefinite"/>
                   </p:stCondLst>
@@ -5954,7 +6180,7 @@
             <a:hlinkClick r:id="" action="ppaction://media"/>
             <a:extLst>
               <a:ext uri="{FF2B5EF4-FFF2-40B4-BE49-F238E27FC236}">
-                <a16:creationId xmlns:a16="http://schemas.microsoft.com/office/drawing/2014/main" id="{5FC8CC9D-0B88-220A-601C-E4E5D2C0878C}"/>
+                <a16:creationId xmlns:a16="http://schemas.microsoft.com/office/drawing/2014/main" id="{52EBFAEC-2F13-99B6-91B1-59F588BDE6FD}"/>
               </a:ext>
             </a:extLst>
           </p:cNvPr>
@@ -5997,7 +6223,65 @@
         <p:cTn id="1" dur="indefinite" restart="never" nodeType="tmRoot">
           <p:childTnLst>
             <p:seq concurrent="1" nextAc="seek">
-              <p:cTn id="2" restart="whenNotActive" fill="hold" evtFilter="cancelBubble" nodeType="interactiveSeq">
+              <p:cTn id="2" dur="indefinite" nodeType="mainSeq">
+                <p:childTnLst>
+                  <p:par>
+                    <p:cTn id="3" fill="hold">
+                      <p:stCondLst>
+                        <p:cond delay="indefinite"/>
+                        <p:cond evt="onBegin" delay="0">
+                          <p:tn val="2"/>
+                        </p:cond>
+                      </p:stCondLst>
+                      <p:childTnLst>
+                        <p:par>
+                          <p:cTn id="4" fill="hold">
+                            <p:stCondLst>
+                              <p:cond delay="0"/>
+                            </p:stCondLst>
+                            <p:childTnLst>
+                              <p:par>
+                                <p:cTn id="5" presetID="1" presetClass="mediacall" presetSubtype="0" fill="hold" nodeType="afterEffect">
+                                  <p:stCondLst>
+                                    <p:cond delay="300"/>
+                                  </p:stCondLst>
+                                  <p:childTnLst>
+                                    <p:cmd type="call" cmd="playFrom(0.0)">
+                                      <p:cBhvr>
+                                        <p:cTn id="6" dur="4493" fill="hold"/>
+                                        <p:tgtEl>
+                                          <p:spTgt spid="6"/>
+                                        </p:tgtEl>
+                                      </p:cBhvr>
+                                    </p:cmd>
+                                  </p:childTnLst>
+                                </p:cTn>
+                              </p:par>
+                            </p:childTnLst>
+                          </p:cTn>
+                        </p:par>
+                      </p:childTnLst>
+                    </p:cTn>
+                  </p:par>
+                </p:childTnLst>
+              </p:cTn>
+              <p:prevCondLst>
+                <p:cond evt="onPrev" delay="0">
+                  <p:tgtEl>
+                    <p:sldTgt/>
+                  </p:tgtEl>
+                </p:cond>
+              </p:prevCondLst>
+              <p:nextCondLst>
+                <p:cond evt="onNext" delay="0">
+                  <p:tgtEl>
+                    <p:sldTgt/>
+                  </p:tgtEl>
+                </p:cond>
+              </p:nextCondLst>
+            </p:seq>
+            <p:seq concurrent="1" nextAc="seek">
+              <p:cTn id="7" restart="whenNotActive" fill="hold" evtFilter="cancelBubble" nodeType="interactiveSeq">
                 <p:stCondLst>
                   <p:cond evt="onClick" delay="0">
                     <p:tgtEl>
@@ -6010,26 +6294,26 @@
                 </p:endSync>
                 <p:childTnLst>
                   <p:par>
-                    <p:cTn id="3" fill="hold">
+                    <p:cTn id="8" fill="hold">
                       <p:stCondLst>
                         <p:cond delay="0"/>
                       </p:stCondLst>
                       <p:childTnLst>
                         <p:par>
-                          <p:cTn id="4" fill="hold">
+                          <p:cTn id="9" fill="hold">
                             <p:stCondLst>
                               <p:cond delay="0"/>
                             </p:stCondLst>
                             <p:childTnLst>
                               <p:par>
-                                <p:cTn id="5" presetID="1" presetClass="mediacall" presetSubtype="0" fill="hold" nodeType="clickEffect">
+                                <p:cTn id="10" presetID="1" presetClass="mediacall" presetSubtype="0" fill="hold" nodeType="clickEffect">
                                   <p:stCondLst>
                                     <p:cond delay="0"/>
                                   </p:stCondLst>
                                   <p:childTnLst>
                                     <p:cmd type="call" cmd="playFrom(0.0)">
                                       <p:cBhvr>
-                                        <p:cTn id="6" dur="4519" fill="hold"/>
+                                        <p:cTn id="11" dur="4519" fill="hold"/>
                                         <p:tgtEl>
                                           <p:spTgt spid="6"/>
                                         </p:tgtEl>
@@ -6056,7 +6340,7 @@
             </p:seq>
             <p:audio>
               <p:cMediaNode vol="80000">
-                <p:cTn id="7" fill="hold" display="0">
+                <p:cTn id="12" fill="hold" display="0">
                   <p:stCondLst>
                     <p:cond delay="indefinite"/>
                   </p:stCondLst>
@@ -6688,7 +6972,7 @@
             <a:hlinkClick r:id="" action="ppaction://media"/>
             <a:extLst>
               <a:ext uri="{FF2B5EF4-FFF2-40B4-BE49-F238E27FC236}">
-                <a16:creationId xmlns:a16="http://schemas.microsoft.com/office/drawing/2014/main" id="{E34777C9-DFF6-0814-F9AF-3E01586FC197}"/>
+                <a16:creationId xmlns:a16="http://schemas.microsoft.com/office/drawing/2014/main" id="{C5C84B64-3EB2-B304-F2D5-D15B52B1E6B5}"/>
               </a:ext>
             </a:extLst>
           </p:cNvPr>
@@ -6736,7 +7020,65 @@
         <p:cTn id="1" dur="indefinite" restart="never" nodeType="tmRoot">
           <p:childTnLst>
             <p:seq concurrent="1" nextAc="seek">
-              <p:cTn id="2" restart="whenNotActive" fill="hold" evtFilter="cancelBubble" nodeType="interactiveSeq">
+              <p:cTn id="2" dur="indefinite" nodeType="mainSeq">
+                <p:childTnLst>
+                  <p:par>
+                    <p:cTn id="3" fill="hold">
+                      <p:stCondLst>
+                        <p:cond delay="indefinite"/>
+                        <p:cond evt="onBegin" delay="0">
+                          <p:tn val="2"/>
+                        </p:cond>
+                      </p:stCondLst>
+                      <p:childTnLst>
+                        <p:par>
+                          <p:cTn id="4" fill="hold">
+                            <p:stCondLst>
+                              <p:cond delay="0"/>
+                            </p:stCondLst>
+                            <p:childTnLst>
+                              <p:par>
+                                <p:cTn id="5" presetID="1" presetClass="mediacall" presetSubtype="0" fill="hold" nodeType="afterEffect">
+                                  <p:stCondLst>
+                                    <p:cond delay="300"/>
+                                  </p:stCondLst>
+                                  <p:childTnLst>
+                                    <p:cmd type="call" cmd="playFrom(0.0)">
+                                      <p:cBhvr>
+                                        <p:cTn id="6" dur="4963" fill="hold"/>
+                                        <p:tgtEl>
+                                          <p:spTgt spid="6"/>
+                                        </p:tgtEl>
+                                      </p:cBhvr>
+                                    </p:cmd>
+                                  </p:childTnLst>
+                                </p:cTn>
+                              </p:par>
+                            </p:childTnLst>
+                          </p:cTn>
+                        </p:par>
+                      </p:childTnLst>
+                    </p:cTn>
+                  </p:par>
+                </p:childTnLst>
+              </p:cTn>
+              <p:prevCondLst>
+                <p:cond evt="onPrev" delay="0">
+                  <p:tgtEl>
+                    <p:sldTgt/>
+                  </p:tgtEl>
+                </p:cond>
+              </p:prevCondLst>
+              <p:nextCondLst>
+                <p:cond evt="onNext" delay="0">
+                  <p:tgtEl>
+                    <p:sldTgt/>
+                  </p:tgtEl>
+                </p:cond>
+              </p:nextCondLst>
+            </p:seq>
+            <p:seq concurrent="1" nextAc="seek">
+              <p:cTn id="7" restart="whenNotActive" fill="hold" evtFilter="cancelBubble" nodeType="interactiveSeq">
                 <p:stCondLst>
                   <p:cond evt="onClick" delay="0">
                     <p:tgtEl>
@@ -6749,26 +7091,26 @@
                 </p:endSync>
                 <p:childTnLst>
                   <p:par>
-                    <p:cTn id="3" fill="hold">
+                    <p:cTn id="8" fill="hold">
                       <p:stCondLst>
                         <p:cond delay="0"/>
                       </p:stCondLst>
                       <p:childTnLst>
                         <p:par>
-                          <p:cTn id="4" fill="hold">
+                          <p:cTn id="9" fill="hold">
                             <p:stCondLst>
                               <p:cond delay="0"/>
                             </p:stCondLst>
                             <p:childTnLst>
                               <p:par>
-                                <p:cTn id="5" presetID="1" presetClass="mediacall" presetSubtype="0" fill="hold" nodeType="clickEffect">
+                                <p:cTn id="10" presetID="1" presetClass="mediacall" presetSubtype="0" fill="hold" nodeType="clickEffect">
                                   <p:stCondLst>
                                     <p:cond delay="0"/>
                                   </p:stCondLst>
                                   <p:childTnLst>
                                     <p:cmd type="call" cmd="playFrom(0.0)">
                                       <p:cBhvr>
-                                        <p:cTn id="6" dur="4989" fill="hold"/>
+                                        <p:cTn id="11" dur="4989" fill="hold"/>
                                         <p:tgtEl>
                                           <p:spTgt spid="6"/>
                                         </p:tgtEl>
@@ -6795,7 +7137,7 @@
             </p:seq>
             <p:audio>
               <p:cMediaNode vol="80000">
-                <p:cTn id="7" fill="hold" display="0">
+                <p:cTn id="12" fill="hold" display="0">
                   <p:stCondLst>
                     <p:cond delay="indefinite"/>
                   </p:stCondLst>
@@ -7475,7 +7817,7 @@
             <a:hlinkClick r:id="" action="ppaction://media"/>
             <a:extLst>
               <a:ext uri="{FF2B5EF4-FFF2-40B4-BE49-F238E27FC236}">
-                <a16:creationId xmlns:a16="http://schemas.microsoft.com/office/drawing/2014/main" id="{D2112204-1A20-39D7-801B-ACA9C28DDAC5}"/>
+                <a16:creationId xmlns:a16="http://schemas.microsoft.com/office/drawing/2014/main" id="{150FEE74-BAF5-8962-C91A-FD74E3C1A95B}"/>
               </a:ext>
             </a:extLst>
           </p:cNvPr>
@@ -7523,7 +7865,65 @@
         <p:cTn id="1" dur="indefinite" restart="never" nodeType="tmRoot">
           <p:childTnLst>
             <p:seq concurrent="1" nextAc="seek">
-              <p:cTn id="2" restart="whenNotActive" fill="hold" evtFilter="cancelBubble" nodeType="interactiveSeq">
+              <p:cTn id="2" dur="indefinite" nodeType="mainSeq">
+                <p:childTnLst>
+                  <p:par>
+                    <p:cTn id="3" fill="hold">
+                      <p:stCondLst>
+                        <p:cond delay="indefinite"/>
+                        <p:cond evt="onBegin" delay="0">
+                          <p:tn val="2"/>
+                        </p:cond>
+                      </p:stCondLst>
+                      <p:childTnLst>
+                        <p:par>
+                          <p:cTn id="4" fill="hold">
+                            <p:stCondLst>
+                              <p:cond delay="0"/>
+                            </p:stCondLst>
+                            <p:childTnLst>
+                              <p:par>
+                                <p:cTn id="5" presetID="1" presetClass="mediacall" presetSubtype="0" fill="hold" nodeType="afterEffect">
+                                  <p:stCondLst>
+                                    <p:cond delay="300"/>
+                                  </p:stCondLst>
+                                  <p:childTnLst>
+                                    <p:cmd type="call" cmd="playFrom(0.0)">
+                                      <p:cBhvr>
+                                        <p:cTn id="6" dur="4859" fill="hold"/>
+                                        <p:tgtEl>
+                                          <p:spTgt spid="6"/>
+                                        </p:tgtEl>
+                                      </p:cBhvr>
+                                    </p:cmd>
+                                  </p:childTnLst>
+                                </p:cTn>
+                              </p:par>
+                            </p:childTnLst>
+                          </p:cTn>
+                        </p:par>
+                      </p:childTnLst>
+                    </p:cTn>
+                  </p:par>
+                </p:childTnLst>
+              </p:cTn>
+              <p:prevCondLst>
+                <p:cond evt="onPrev" delay="0">
+                  <p:tgtEl>
+                    <p:sldTgt/>
+                  </p:tgtEl>
+                </p:cond>
+              </p:prevCondLst>
+              <p:nextCondLst>
+                <p:cond evt="onNext" delay="0">
+                  <p:tgtEl>
+                    <p:sldTgt/>
+                  </p:tgtEl>
+                </p:cond>
+              </p:nextCondLst>
+            </p:seq>
+            <p:seq concurrent="1" nextAc="seek">
+              <p:cTn id="7" restart="whenNotActive" fill="hold" evtFilter="cancelBubble" nodeType="interactiveSeq">
                 <p:stCondLst>
                   <p:cond evt="onClick" delay="0">
                     <p:tgtEl>
@@ -7536,26 +7936,26 @@
                 </p:endSync>
                 <p:childTnLst>
                   <p:par>
-                    <p:cTn id="3" fill="hold">
+                    <p:cTn id="8" fill="hold">
                       <p:stCondLst>
                         <p:cond delay="0"/>
                       </p:stCondLst>
                       <p:childTnLst>
                         <p:par>
-                          <p:cTn id="4" fill="hold">
+                          <p:cTn id="9" fill="hold">
                             <p:stCondLst>
                               <p:cond delay="0"/>
                             </p:stCondLst>
                             <p:childTnLst>
                               <p:par>
-                                <p:cTn id="5" presetID="1" presetClass="mediacall" presetSubtype="0" fill="hold" nodeType="clickEffect">
+                                <p:cTn id="10" presetID="1" presetClass="mediacall" presetSubtype="0" fill="hold" nodeType="clickEffect">
                                   <p:stCondLst>
                                     <p:cond delay="0"/>
                                   </p:stCondLst>
                                   <p:childTnLst>
                                     <p:cmd type="call" cmd="playFrom(0.0)">
                                       <p:cBhvr>
-                                        <p:cTn id="6" dur="4884" fill="hold"/>
+                                        <p:cTn id="11" dur="4884" fill="hold"/>
                                         <p:tgtEl>
                                           <p:spTgt spid="6"/>
                                         </p:tgtEl>
@@ -7582,7 +7982,7 @@
             </p:seq>
             <p:audio>
               <p:cMediaNode vol="80000">
-                <p:cTn id="7" fill="hold" display="0">
+                <p:cTn id="12" fill="hold" display="0">
                   <p:stCondLst>
                     <p:cond delay="indefinite"/>
                   </p:stCondLst>
@@ -8310,7 +8710,7 @@
             <a:hlinkClick r:id="" action="ppaction://media"/>
             <a:extLst>
               <a:ext uri="{FF2B5EF4-FFF2-40B4-BE49-F238E27FC236}">
-                <a16:creationId xmlns:a16="http://schemas.microsoft.com/office/drawing/2014/main" id="{F7C56216-41DD-470E-122C-40D9420736DC}"/>
+                <a16:creationId xmlns:a16="http://schemas.microsoft.com/office/drawing/2014/main" id="{EF498C07-1311-1763-69E4-9063746CD2D4}"/>
               </a:ext>
             </a:extLst>
           </p:cNvPr>
@@ -8358,7 +8758,65 @@
         <p:cTn id="1" dur="indefinite" restart="never" nodeType="tmRoot">
           <p:childTnLst>
             <p:seq concurrent="1" nextAc="seek">
-              <p:cTn id="2" restart="whenNotActive" fill="hold" evtFilter="cancelBubble" nodeType="interactiveSeq">
+              <p:cTn id="2" dur="indefinite" nodeType="mainSeq">
+                <p:childTnLst>
+                  <p:par>
+                    <p:cTn id="3" fill="hold">
+                      <p:stCondLst>
+                        <p:cond delay="indefinite"/>
+                        <p:cond evt="onBegin" delay="0">
+                          <p:tn val="2"/>
+                        </p:cond>
+                      </p:stCondLst>
+                      <p:childTnLst>
+                        <p:par>
+                          <p:cTn id="4" fill="hold">
+                            <p:stCondLst>
+                              <p:cond delay="0"/>
+                            </p:stCondLst>
+                            <p:childTnLst>
+                              <p:par>
+                                <p:cTn id="5" presetID="1" presetClass="mediacall" presetSubtype="0" fill="hold" nodeType="afterEffect">
+                                  <p:stCondLst>
+                                    <p:cond delay="300"/>
+                                  </p:stCondLst>
+                                  <p:childTnLst>
+                                    <p:cmd type="call" cmd="playFrom(0.0)">
+                                      <p:cBhvr>
+                                        <p:cTn id="6" dur="4833" fill="hold"/>
+                                        <p:tgtEl>
+                                          <p:spTgt spid="6"/>
+                                        </p:tgtEl>
+                                      </p:cBhvr>
+                                    </p:cmd>
+                                  </p:childTnLst>
+                                </p:cTn>
+                              </p:par>
+                            </p:childTnLst>
+                          </p:cTn>
+                        </p:par>
+                      </p:childTnLst>
+                    </p:cTn>
+                  </p:par>
+                </p:childTnLst>
+              </p:cTn>
+              <p:prevCondLst>
+                <p:cond evt="onPrev" delay="0">
+                  <p:tgtEl>
+                    <p:sldTgt/>
+                  </p:tgtEl>
+                </p:cond>
+              </p:prevCondLst>
+              <p:nextCondLst>
+                <p:cond evt="onNext" delay="0">
+                  <p:tgtEl>
+                    <p:sldTgt/>
+                  </p:tgtEl>
+                </p:cond>
+              </p:nextCondLst>
+            </p:seq>
+            <p:seq concurrent="1" nextAc="seek">
+              <p:cTn id="7" restart="whenNotActive" fill="hold" evtFilter="cancelBubble" nodeType="interactiveSeq">
                 <p:stCondLst>
                   <p:cond evt="onClick" delay="0">
                     <p:tgtEl>
@@ -8371,26 +8829,26 @@
                 </p:endSync>
                 <p:childTnLst>
                   <p:par>
-                    <p:cTn id="3" fill="hold">
+                    <p:cTn id="8" fill="hold">
                       <p:stCondLst>
                         <p:cond delay="0"/>
                       </p:stCondLst>
                       <p:childTnLst>
                         <p:par>
-                          <p:cTn id="4" fill="hold">
+                          <p:cTn id="9" fill="hold">
                             <p:stCondLst>
                               <p:cond delay="0"/>
                             </p:stCondLst>
                             <p:childTnLst>
                               <p:par>
-                                <p:cTn id="5" presetID="1" presetClass="mediacall" presetSubtype="0" fill="hold" nodeType="clickEffect">
+                                <p:cTn id="10" presetID="1" presetClass="mediacall" presetSubtype="0" fill="hold" nodeType="clickEffect">
                                   <p:stCondLst>
                                     <p:cond delay="0"/>
                                   </p:stCondLst>
                                   <p:childTnLst>
                                     <p:cmd type="call" cmd="playFrom(0.0)">
                                       <p:cBhvr>
-                                        <p:cTn id="6" dur="4858" fill="hold"/>
+                                        <p:cTn id="11" dur="4858" fill="hold"/>
                                         <p:tgtEl>
                                           <p:spTgt spid="6"/>
                                         </p:tgtEl>
@@ -8417,7 +8875,7 @@
             </p:seq>
             <p:audio>
               <p:cMediaNode vol="80000">
-                <p:cTn id="7" fill="hold" display="0">
+                <p:cTn id="12" fill="hold" display="0">
                   <p:stCondLst>
                     <p:cond delay="indefinite"/>
                   </p:stCondLst>
@@ -8941,7 +9399,7 @@
             <a:hlinkClick r:id="" action="ppaction://media"/>
             <a:extLst>
               <a:ext uri="{FF2B5EF4-FFF2-40B4-BE49-F238E27FC236}">
-                <a16:creationId xmlns:a16="http://schemas.microsoft.com/office/drawing/2014/main" id="{204A6FBE-0CEE-28EB-4638-B29F833CB366}"/>
+                <a16:creationId xmlns:a16="http://schemas.microsoft.com/office/drawing/2014/main" id="{68BB2564-9198-8CCF-EC83-C7DDCBFD73E0}"/>
               </a:ext>
             </a:extLst>
           </p:cNvPr>
@@ -8979,7 +9437,7 @@
             <a:hlinkClick r:id="" action="ppaction://media"/>
             <a:extLst>
               <a:ext uri="{FF2B5EF4-FFF2-40B4-BE49-F238E27FC236}">
-                <a16:creationId xmlns:a16="http://schemas.microsoft.com/office/drawing/2014/main" id="{3DA9C571-6335-1E51-E454-D7667BEE5AC7}"/>
+                <a16:creationId xmlns:a16="http://schemas.microsoft.com/office/drawing/2014/main" id="{D073356A-C47C-757E-E1E3-B70302FF5DD0}"/>
               </a:ext>
             </a:extLst>
           </p:cNvPr>
@@ -9017,7 +9475,7 @@
             <a:hlinkClick r:id="" action="ppaction://media"/>
             <a:extLst>
               <a:ext uri="{FF2B5EF4-FFF2-40B4-BE49-F238E27FC236}">
-                <a16:creationId xmlns:a16="http://schemas.microsoft.com/office/drawing/2014/main" id="{F19C6E41-7B7E-7B62-FE7A-6089140B502D}"/>
+                <a16:creationId xmlns:a16="http://schemas.microsoft.com/office/drawing/2014/main" id="{219712B1-5ABA-4EC2-F390-DE4120E66197}"/>
               </a:ext>
             </a:extLst>
           </p:cNvPr>
@@ -9060,7 +9518,117 @@
         <p:cTn id="1" dur="indefinite" restart="never" nodeType="tmRoot">
           <p:childTnLst>
             <p:seq concurrent="1" nextAc="seek">
-              <p:cTn id="2" restart="whenNotActive" fill="hold" evtFilter="cancelBubble" nodeType="interactiveSeq">
+              <p:cTn id="2" dur="indefinite" nodeType="mainSeq">
+                <p:childTnLst>
+                  <p:par>
+                    <p:cTn id="3" fill="hold">
+                      <p:stCondLst>
+                        <p:cond delay="indefinite"/>
+                        <p:cond evt="onBegin" delay="0">
+                          <p:tn val="2"/>
+                        </p:cond>
+                      </p:stCondLst>
+                      <p:childTnLst>
+                        <p:par>
+                          <p:cTn id="4" fill="hold">
+                            <p:stCondLst>
+                              <p:cond delay="0"/>
+                            </p:stCondLst>
+                            <p:childTnLst>
+                              <p:par>
+                                <p:cTn id="5" presetID="1" presetClass="mediacall" presetSubtype="0" fill="hold" nodeType="afterEffect">
+                                  <p:stCondLst>
+                                    <p:cond delay="300"/>
+                                  </p:stCondLst>
+                                  <p:childTnLst>
+                                    <p:cmd type="call" cmd="playFrom(0.0)">
+                                      <p:cBhvr>
+                                        <p:cTn id="6" dur="784" fill="hold"/>
+                                        <p:tgtEl>
+                                          <p:spTgt spid="5"/>
+                                        </p:tgtEl>
+                                      </p:cBhvr>
+                                    </p:cmd>
+                                  </p:childTnLst>
+                                </p:cTn>
+                              </p:par>
+                            </p:childTnLst>
+                          </p:cTn>
+                        </p:par>
+                        <p:par>
+                          <p:cTn id="7" fill="hold">
+                            <p:stCondLst>
+                              <p:cond delay="1109"/>
+                            </p:stCondLst>
+                            <p:childTnLst>
+                              <p:par>
+                                <p:cTn id="8" presetID="1" presetClass="mediacall" presetSubtype="0" fill="hold" nodeType="afterEffect">
+                                  <p:stCondLst>
+                                    <p:cond delay="300"/>
+                                  </p:stCondLst>
+                                  <p:childTnLst>
+                                    <p:cmd type="call" cmd="playFrom(0.0)">
+                                      <p:cBhvr>
+                                        <p:cTn id="9" dur="784" fill="hold"/>
+                                        <p:tgtEl>
+                                          <p:spTgt spid="6"/>
+                                        </p:tgtEl>
+                                      </p:cBhvr>
+                                    </p:cmd>
+                                  </p:childTnLst>
+                                </p:cTn>
+                              </p:par>
+                            </p:childTnLst>
+                          </p:cTn>
+                        </p:par>
+                        <p:par>
+                          <p:cTn id="10" fill="hold">
+                            <p:stCondLst>
+                              <p:cond delay="2218"/>
+                            </p:stCondLst>
+                            <p:childTnLst>
+                              <p:par>
+                                <p:cTn id="11" presetID="1" presetClass="mediacall" presetSubtype="0" fill="hold" nodeType="afterEffect">
+                                  <p:stCondLst>
+                                    <p:cond delay="300"/>
+                                  </p:stCondLst>
+                                  <p:childTnLst>
+                                    <p:cmd type="call" cmd="playFrom(0.0)">
+                                      <p:cBhvr>
+                                        <p:cTn id="12" dur="2403" fill="hold"/>
+                                        <p:tgtEl>
+                                          <p:spTgt spid="11"/>
+                                        </p:tgtEl>
+                                      </p:cBhvr>
+                                    </p:cmd>
+                                  </p:childTnLst>
+                                </p:cTn>
+                              </p:par>
+                            </p:childTnLst>
+                          </p:cTn>
+                        </p:par>
+                      </p:childTnLst>
+                    </p:cTn>
+                  </p:par>
+                </p:childTnLst>
+              </p:cTn>
+              <p:prevCondLst>
+                <p:cond evt="onPrev" delay="0">
+                  <p:tgtEl>
+                    <p:sldTgt/>
+                  </p:tgtEl>
+                </p:cond>
+              </p:prevCondLst>
+              <p:nextCondLst>
+                <p:cond evt="onNext" delay="0">
+                  <p:tgtEl>
+                    <p:sldTgt/>
+                  </p:tgtEl>
+                </p:cond>
+              </p:nextCondLst>
+            </p:seq>
+            <p:seq concurrent="1" nextAc="seek">
+              <p:cTn id="13" restart="whenNotActive" fill="hold" evtFilter="cancelBubble" nodeType="interactiveSeq">
                 <p:stCondLst>
                   <p:cond evt="onClick" delay="0">
                     <p:tgtEl>
@@ -9073,26 +9641,26 @@
                 </p:endSync>
                 <p:childTnLst>
                   <p:par>
-                    <p:cTn id="3" fill="hold">
+                    <p:cTn id="14" fill="hold">
                       <p:stCondLst>
                         <p:cond delay="0"/>
                       </p:stCondLst>
                       <p:childTnLst>
                         <p:par>
-                          <p:cTn id="4" fill="hold">
+                          <p:cTn id="15" fill="hold">
                             <p:stCondLst>
                               <p:cond delay="0"/>
                             </p:stCondLst>
                             <p:childTnLst>
                               <p:par>
-                                <p:cTn id="5" presetID="1" presetClass="mediacall" presetSubtype="0" fill="hold" nodeType="clickEffect">
+                                <p:cTn id="16" presetID="1" presetClass="mediacall" presetSubtype="0" fill="hold" nodeType="clickEffect">
                                   <p:stCondLst>
                                     <p:cond delay="0"/>
                                   </p:stCondLst>
                                   <p:childTnLst>
                                     <p:cmd type="call" cmd="playFrom(0.0)">
                                       <p:cBhvr>
-                                        <p:cTn id="6" dur="809" fill="hold"/>
+                                        <p:cTn id="17" dur="809" fill="hold"/>
                                         <p:tgtEl>
                                           <p:spTgt spid="5"/>
                                         </p:tgtEl>
@@ -9119,7 +9687,7 @@
             </p:seq>
             <p:audio>
               <p:cMediaNode vol="80000">
-                <p:cTn id="7" fill="hold" display="0">
+                <p:cTn id="18" fill="hold" display="0">
                   <p:stCondLst>
                     <p:cond delay="indefinite"/>
                   </p:stCondLst>
@@ -9137,7 +9705,7 @@
               </p:cMediaNode>
             </p:audio>
             <p:seq concurrent="1" nextAc="seek">
-              <p:cTn id="8" restart="whenNotActive" fill="hold" evtFilter="cancelBubble" nodeType="interactiveSeq">
+              <p:cTn id="19" restart="whenNotActive" fill="hold" evtFilter="cancelBubble" nodeType="interactiveSeq">
                 <p:stCondLst>
                   <p:cond evt="onClick" delay="0">
                     <p:tgtEl>
@@ -9150,26 +9718,26 @@
                 </p:endSync>
                 <p:childTnLst>
                   <p:par>
-                    <p:cTn id="9" fill="hold">
+                    <p:cTn id="20" fill="hold">
                       <p:stCondLst>
                         <p:cond delay="0"/>
                       </p:stCondLst>
                       <p:childTnLst>
                         <p:par>
-                          <p:cTn id="10" fill="hold">
+                          <p:cTn id="21" fill="hold">
                             <p:stCondLst>
                               <p:cond delay="0"/>
                             </p:stCondLst>
                             <p:childTnLst>
                               <p:par>
-                                <p:cTn id="11" presetID="1" presetClass="mediacall" presetSubtype="0" fill="hold" nodeType="clickEffect">
+                                <p:cTn id="22" presetID="1" presetClass="mediacall" presetSubtype="0" fill="hold" nodeType="clickEffect">
                                   <p:stCondLst>
                                     <p:cond delay="0"/>
                                   </p:stCondLst>
                                   <p:childTnLst>
                                     <p:cmd type="call" cmd="playFrom(0.0)">
                                       <p:cBhvr>
-                                        <p:cTn id="12" dur="809" fill="hold"/>
+                                        <p:cTn id="23" dur="809" fill="hold"/>
                                         <p:tgtEl>
                                           <p:spTgt spid="6"/>
                                         </p:tgtEl>
@@ -9196,7 +9764,7 @@
             </p:seq>
             <p:audio>
               <p:cMediaNode vol="80000">
-                <p:cTn id="13" fill="hold" display="0">
+                <p:cTn id="24" fill="hold" display="0">
                   <p:stCondLst>
                     <p:cond delay="indefinite"/>
                   </p:stCondLst>
@@ -9214,7 +9782,7 @@
               </p:cMediaNode>
             </p:audio>
             <p:seq concurrent="1" nextAc="seek">
-              <p:cTn id="14" restart="whenNotActive" fill="hold" evtFilter="cancelBubble" nodeType="interactiveSeq">
+              <p:cTn id="25" restart="whenNotActive" fill="hold" evtFilter="cancelBubble" nodeType="interactiveSeq">
                 <p:stCondLst>
                   <p:cond evt="onClick" delay="0">
                     <p:tgtEl>
@@ -9227,26 +9795,26 @@
                 </p:endSync>
                 <p:childTnLst>
                   <p:par>
-                    <p:cTn id="15" fill="hold">
+                    <p:cTn id="26" fill="hold">
                       <p:stCondLst>
                         <p:cond delay="0"/>
                       </p:stCondLst>
                       <p:childTnLst>
                         <p:par>
-                          <p:cTn id="16" fill="hold">
+                          <p:cTn id="27" fill="hold">
                             <p:stCondLst>
                               <p:cond delay="0"/>
                             </p:stCondLst>
                             <p:childTnLst>
                               <p:par>
-                                <p:cTn id="17" presetID="1" presetClass="mediacall" presetSubtype="0" fill="hold" nodeType="clickEffect">
+                                <p:cTn id="28" presetID="1" presetClass="mediacall" presetSubtype="0" fill="hold" nodeType="clickEffect">
                                   <p:stCondLst>
                                     <p:cond delay="0"/>
                                   </p:stCondLst>
                                   <p:childTnLst>
                                     <p:cmd type="call" cmd="playFrom(0.0)">
                                       <p:cBhvr>
-                                        <p:cTn id="18" dur="2429" fill="hold"/>
+                                        <p:cTn id="29" dur="2429" fill="hold"/>
                                         <p:tgtEl>
                                           <p:spTgt spid="11"/>
                                         </p:tgtEl>
@@ -9273,7 +9841,7 @@
             </p:seq>
             <p:audio>
               <p:cMediaNode vol="80000">
-                <p:cTn id="19" fill="hold" display="0">
+                <p:cTn id="30" fill="hold" display="0">
                   <p:stCondLst>
                     <p:cond delay="indefinite"/>
                   </p:stCondLst>
@@ -9861,7 +10429,7 @@
             <a:hlinkClick r:id="" action="ppaction://media"/>
             <a:extLst>
               <a:ext uri="{FF2B5EF4-FFF2-40B4-BE49-F238E27FC236}">
-                <a16:creationId xmlns:a16="http://schemas.microsoft.com/office/drawing/2014/main" id="{3CAAEBAD-9594-3B10-0567-629A9F5FCF49}"/>
+                <a16:creationId xmlns:a16="http://schemas.microsoft.com/office/drawing/2014/main" id="{5F74F083-73AC-F60B-25B4-4273CB88F453}"/>
               </a:ext>
             </a:extLst>
           </p:cNvPr>
@@ -9904,7 +10472,65 @@
         <p:cTn id="1" dur="indefinite" restart="never" nodeType="tmRoot">
           <p:childTnLst>
             <p:seq concurrent="1" nextAc="seek">
-              <p:cTn id="2" restart="whenNotActive" fill="hold" evtFilter="cancelBubble" nodeType="interactiveSeq">
+              <p:cTn id="2" dur="indefinite" nodeType="mainSeq">
+                <p:childTnLst>
+                  <p:par>
+                    <p:cTn id="3" fill="hold">
+                      <p:stCondLst>
+                        <p:cond delay="indefinite"/>
+                        <p:cond evt="onBegin" delay="0">
+                          <p:tn val="2"/>
+                        </p:cond>
+                      </p:stCondLst>
+                      <p:childTnLst>
+                        <p:par>
+                          <p:cTn id="4" fill="hold">
+                            <p:stCondLst>
+                              <p:cond delay="0"/>
+                            </p:stCondLst>
+                            <p:childTnLst>
+                              <p:par>
+                                <p:cTn id="5" presetID="1" presetClass="mediacall" presetSubtype="0" fill="hold" nodeType="afterEffect">
+                                  <p:stCondLst>
+                                    <p:cond delay="300"/>
+                                  </p:stCondLst>
+                                  <p:childTnLst>
+                                    <p:cmd type="call" cmd="playFrom(0.0)">
+                                      <p:cBhvr>
+                                        <p:cTn id="6" dur="4362" fill="hold"/>
+                                        <p:tgtEl>
+                                          <p:spTgt spid="6"/>
+                                        </p:tgtEl>
+                                      </p:cBhvr>
+                                    </p:cmd>
+                                  </p:childTnLst>
+                                </p:cTn>
+                              </p:par>
+                            </p:childTnLst>
+                          </p:cTn>
+                        </p:par>
+                      </p:childTnLst>
+                    </p:cTn>
+                  </p:par>
+                </p:childTnLst>
+              </p:cTn>
+              <p:prevCondLst>
+                <p:cond evt="onPrev" delay="0">
+                  <p:tgtEl>
+                    <p:sldTgt/>
+                  </p:tgtEl>
+                </p:cond>
+              </p:prevCondLst>
+              <p:nextCondLst>
+                <p:cond evt="onNext" delay="0">
+                  <p:tgtEl>
+                    <p:sldTgt/>
+                  </p:tgtEl>
+                </p:cond>
+              </p:nextCondLst>
+            </p:seq>
+            <p:seq concurrent="1" nextAc="seek">
+              <p:cTn id="7" restart="whenNotActive" fill="hold" evtFilter="cancelBubble" nodeType="interactiveSeq">
                 <p:stCondLst>
                   <p:cond evt="onClick" delay="0">
                     <p:tgtEl>
@@ -9917,26 +10543,26 @@
                 </p:endSync>
                 <p:childTnLst>
                   <p:par>
-                    <p:cTn id="3" fill="hold">
+                    <p:cTn id="8" fill="hold">
                       <p:stCondLst>
                         <p:cond delay="0"/>
                       </p:stCondLst>
                       <p:childTnLst>
                         <p:par>
-                          <p:cTn id="4" fill="hold">
+                          <p:cTn id="9" fill="hold">
                             <p:stCondLst>
                               <p:cond delay="0"/>
                             </p:stCondLst>
                             <p:childTnLst>
                               <p:par>
-                                <p:cTn id="5" presetID="1" presetClass="mediacall" presetSubtype="0" fill="hold" nodeType="clickEffect">
+                                <p:cTn id="10" presetID="1" presetClass="mediacall" presetSubtype="0" fill="hold" nodeType="clickEffect">
                                   <p:stCondLst>
                                     <p:cond delay="0"/>
                                   </p:stCondLst>
                                   <p:childTnLst>
                                     <p:cmd type="call" cmd="playFrom(0.0)">
                                       <p:cBhvr>
-                                        <p:cTn id="6" dur="4388" fill="hold"/>
+                                        <p:cTn id="11" dur="4388" fill="hold"/>
                                         <p:tgtEl>
                                           <p:spTgt spid="6"/>
                                         </p:tgtEl>
@@ -9963,7 +10589,7 @@
             </p:seq>
             <p:audio>
               <p:cMediaNode vol="80000">
-                <p:cTn id="7" fill="hold" display="0">
+                <p:cTn id="12" fill="hold" display="0">
                   <p:stCondLst>
                     <p:cond delay="indefinite"/>
                   </p:stCondLst>
@@ -10599,7 +11225,7 @@
             <a:hlinkClick r:id="" action="ppaction://media"/>
             <a:extLst>
               <a:ext uri="{FF2B5EF4-FFF2-40B4-BE49-F238E27FC236}">
-                <a16:creationId xmlns:a16="http://schemas.microsoft.com/office/drawing/2014/main" id="{1C566140-8FA6-CAB1-310D-737043D37DDA}"/>
+                <a16:creationId xmlns:a16="http://schemas.microsoft.com/office/drawing/2014/main" id="{6C615693-84C1-9EF9-8045-0F6C9C0F3053}"/>
               </a:ext>
             </a:extLst>
           </p:cNvPr>
@@ -10642,7 +11268,65 @@
         <p:cTn id="1" dur="indefinite" restart="never" nodeType="tmRoot">
           <p:childTnLst>
             <p:seq concurrent="1" nextAc="seek">
-              <p:cTn id="2" restart="whenNotActive" fill="hold" evtFilter="cancelBubble" nodeType="interactiveSeq">
+              <p:cTn id="2" dur="indefinite" nodeType="mainSeq">
+                <p:childTnLst>
+                  <p:par>
+                    <p:cTn id="3" fill="hold">
+                      <p:stCondLst>
+                        <p:cond delay="indefinite"/>
+                        <p:cond evt="onBegin" delay="0">
+                          <p:tn val="2"/>
+                        </p:cond>
+                      </p:stCondLst>
+                      <p:childTnLst>
+                        <p:par>
+                          <p:cTn id="4" fill="hold">
+                            <p:stCondLst>
+                              <p:cond delay="0"/>
+                            </p:stCondLst>
+                            <p:childTnLst>
+                              <p:par>
+                                <p:cTn id="5" presetID="1" presetClass="mediacall" presetSubtype="0" fill="hold" nodeType="afterEffect">
+                                  <p:stCondLst>
+                                    <p:cond delay="300"/>
+                                  </p:stCondLst>
+                                  <p:childTnLst>
+                                    <p:cmd type="call" cmd="playFrom(0.0)">
+                                      <p:cBhvr>
+                                        <p:cTn id="6" dur="4075" fill="hold"/>
+                                        <p:tgtEl>
+                                          <p:spTgt spid="6"/>
+                                        </p:tgtEl>
+                                      </p:cBhvr>
+                                    </p:cmd>
+                                  </p:childTnLst>
+                                </p:cTn>
+                              </p:par>
+                            </p:childTnLst>
+                          </p:cTn>
+                        </p:par>
+                      </p:childTnLst>
+                    </p:cTn>
+                  </p:par>
+                </p:childTnLst>
+              </p:cTn>
+              <p:prevCondLst>
+                <p:cond evt="onPrev" delay="0">
+                  <p:tgtEl>
+                    <p:sldTgt/>
+                  </p:tgtEl>
+                </p:cond>
+              </p:prevCondLst>
+              <p:nextCondLst>
+                <p:cond evt="onNext" delay="0">
+                  <p:tgtEl>
+                    <p:sldTgt/>
+                  </p:tgtEl>
+                </p:cond>
+              </p:nextCondLst>
+            </p:seq>
+            <p:seq concurrent="1" nextAc="seek">
+              <p:cTn id="7" restart="whenNotActive" fill="hold" evtFilter="cancelBubble" nodeType="interactiveSeq">
                 <p:stCondLst>
                   <p:cond evt="onClick" delay="0">
                     <p:tgtEl>
@@ -10655,26 +11339,26 @@
                 </p:endSync>
                 <p:childTnLst>
                   <p:par>
-                    <p:cTn id="3" fill="hold">
+                    <p:cTn id="8" fill="hold">
                       <p:stCondLst>
                         <p:cond delay="0"/>
                       </p:stCondLst>
                       <p:childTnLst>
                         <p:par>
-                          <p:cTn id="4" fill="hold">
+                          <p:cTn id="9" fill="hold">
                             <p:stCondLst>
                               <p:cond delay="0"/>
                             </p:stCondLst>
                             <p:childTnLst>
                               <p:par>
-                                <p:cTn id="5" presetID="1" presetClass="mediacall" presetSubtype="0" fill="hold" nodeType="clickEffect">
+                                <p:cTn id="10" presetID="1" presetClass="mediacall" presetSubtype="0" fill="hold" nodeType="clickEffect">
                                   <p:stCondLst>
                                     <p:cond delay="0"/>
                                   </p:stCondLst>
                                   <p:childTnLst>
                                     <p:cmd type="call" cmd="playFrom(0.0)">
                                       <p:cBhvr>
-                                        <p:cTn id="6" dur="4101" fill="hold"/>
+                                        <p:cTn id="11" dur="4101" fill="hold"/>
                                         <p:tgtEl>
                                           <p:spTgt spid="6"/>
                                         </p:tgtEl>
@@ -10701,7 +11385,7 @@
             </p:seq>
             <p:audio>
               <p:cMediaNode vol="80000">
-                <p:cTn id="7" fill="hold" display="0">
+                <p:cTn id="12" fill="hold" display="0">
                   <p:stCondLst>
                     <p:cond delay="indefinite"/>
                   </p:stCondLst>
@@ -11385,7 +12069,7 @@
             <a:hlinkClick r:id="" action="ppaction://media"/>
             <a:extLst>
               <a:ext uri="{FF2B5EF4-FFF2-40B4-BE49-F238E27FC236}">
-                <a16:creationId xmlns:a16="http://schemas.microsoft.com/office/drawing/2014/main" id="{CB48E714-B416-71CD-D2BB-82B311439CD5}"/>
+                <a16:creationId xmlns:a16="http://schemas.microsoft.com/office/drawing/2014/main" id="{A5DCA260-FEBC-FEE8-FE2F-182C11F2B188}"/>
               </a:ext>
             </a:extLst>
           </p:cNvPr>
@@ -11428,7 +12112,65 @@
         <p:cTn id="1" dur="indefinite" restart="never" nodeType="tmRoot">
           <p:childTnLst>
             <p:seq concurrent="1" nextAc="seek">
-              <p:cTn id="2" restart="whenNotActive" fill="hold" evtFilter="cancelBubble" nodeType="interactiveSeq">
+              <p:cTn id="2" dur="indefinite" nodeType="mainSeq">
+                <p:childTnLst>
+                  <p:par>
+                    <p:cTn id="3" fill="hold">
+                      <p:stCondLst>
+                        <p:cond delay="indefinite"/>
+                        <p:cond evt="onBegin" delay="0">
+                          <p:tn val="2"/>
+                        </p:cond>
+                      </p:stCondLst>
+                      <p:childTnLst>
+                        <p:par>
+                          <p:cTn id="4" fill="hold">
+                            <p:stCondLst>
+                              <p:cond delay="0"/>
+                            </p:stCondLst>
+                            <p:childTnLst>
+                              <p:par>
+                                <p:cTn id="5" presetID="1" presetClass="mediacall" presetSubtype="0" fill="hold" nodeType="afterEffect">
+                                  <p:stCondLst>
+                                    <p:cond delay="300"/>
+                                  </p:stCondLst>
+                                  <p:childTnLst>
+                                    <p:cmd type="call" cmd="playFrom(0.0)">
+                                      <p:cBhvr>
+                                        <p:cTn id="6" dur="4728" fill="hold"/>
+                                        <p:tgtEl>
+                                          <p:spTgt spid="6"/>
+                                        </p:tgtEl>
+                                      </p:cBhvr>
+                                    </p:cmd>
+                                  </p:childTnLst>
+                                </p:cTn>
+                              </p:par>
+                            </p:childTnLst>
+                          </p:cTn>
+                        </p:par>
+                      </p:childTnLst>
+                    </p:cTn>
+                  </p:par>
+                </p:childTnLst>
+              </p:cTn>
+              <p:prevCondLst>
+                <p:cond evt="onPrev" delay="0">
+                  <p:tgtEl>
+                    <p:sldTgt/>
+                  </p:tgtEl>
+                </p:cond>
+              </p:prevCondLst>
+              <p:nextCondLst>
+                <p:cond evt="onNext" delay="0">
+                  <p:tgtEl>
+                    <p:sldTgt/>
+                  </p:tgtEl>
+                </p:cond>
+              </p:nextCondLst>
+            </p:seq>
+            <p:seq concurrent="1" nextAc="seek">
+              <p:cTn id="7" restart="whenNotActive" fill="hold" evtFilter="cancelBubble" nodeType="interactiveSeq">
                 <p:stCondLst>
                   <p:cond evt="onClick" delay="0">
                     <p:tgtEl>
@@ -11441,26 +12183,26 @@
                 </p:endSync>
                 <p:childTnLst>
                   <p:par>
-                    <p:cTn id="3" fill="hold">
+                    <p:cTn id="8" fill="hold">
                       <p:stCondLst>
                         <p:cond delay="0"/>
                       </p:stCondLst>
                       <p:childTnLst>
                         <p:par>
-                          <p:cTn id="4" fill="hold">
+                          <p:cTn id="9" fill="hold">
                             <p:stCondLst>
                               <p:cond delay="0"/>
                             </p:stCondLst>
                             <p:childTnLst>
                               <p:par>
-                                <p:cTn id="5" presetID="1" presetClass="mediacall" presetSubtype="0" fill="hold" nodeType="clickEffect">
+                                <p:cTn id="10" presetID="1" presetClass="mediacall" presetSubtype="0" fill="hold" nodeType="clickEffect">
                                   <p:stCondLst>
                                     <p:cond delay="0"/>
                                   </p:stCondLst>
                                   <p:childTnLst>
                                     <p:cmd type="call" cmd="playFrom(0.0)">
                                       <p:cBhvr>
-                                        <p:cTn id="6" dur="4754" fill="hold"/>
+                                        <p:cTn id="11" dur="4754" fill="hold"/>
                                         <p:tgtEl>
                                           <p:spTgt spid="6"/>
                                         </p:tgtEl>
@@ -11487,7 +12229,7 @@
             </p:seq>
             <p:audio>
               <p:cMediaNode vol="80000">
-                <p:cTn id="7" fill="hold" display="0">
+                <p:cTn id="12" fill="hold" display="0">
                   <p:stCondLst>
                     <p:cond delay="indefinite"/>
                   </p:stCondLst>
@@ -11978,7 +12720,7 @@
             <a:hlinkClick r:id="" action="ppaction://media"/>
             <a:extLst>
               <a:ext uri="{FF2B5EF4-FFF2-40B4-BE49-F238E27FC236}">
-                <a16:creationId xmlns:a16="http://schemas.microsoft.com/office/drawing/2014/main" id="{795A63C1-A459-E227-FED7-CB9A4B56EF05}"/>
+                <a16:creationId xmlns:a16="http://schemas.microsoft.com/office/drawing/2014/main" id="{05B58CCF-A8CE-E433-B09C-D0902C2FFEDF}"/>
               </a:ext>
             </a:extLst>
           </p:cNvPr>
@@ -12016,7 +12758,7 @@
             <a:hlinkClick r:id="" action="ppaction://media"/>
             <a:extLst>
               <a:ext uri="{FF2B5EF4-FFF2-40B4-BE49-F238E27FC236}">
-                <a16:creationId xmlns:a16="http://schemas.microsoft.com/office/drawing/2014/main" id="{9C93A9B5-256F-CB70-A1DE-4514680185B6}"/>
+                <a16:creationId xmlns:a16="http://schemas.microsoft.com/office/drawing/2014/main" id="{E54587E5-FE53-7FE9-68BA-59E55B5B851F}"/>
               </a:ext>
             </a:extLst>
           </p:cNvPr>
@@ -12054,7 +12796,7 @@
             <a:hlinkClick r:id="" action="ppaction://media"/>
             <a:extLst>
               <a:ext uri="{FF2B5EF4-FFF2-40B4-BE49-F238E27FC236}">
-                <a16:creationId xmlns:a16="http://schemas.microsoft.com/office/drawing/2014/main" id="{B1900CAC-700C-F73D-35B6-AA0ADC1FE2A2}"/>
+                <a16:creationId xmlns:a16="http://schemas.microsoft.com/office/drawing/2014/main" id="{5537C46D-5F28-3ECE-E2B1-B99308DFFE86}"/>
               </a:ext>
             </a:extLst>
           </p:cNvPr>
@@ -12097,7 +12839,117 @@
         <p:cTn id="1" dur="indefinite" restart="never" nodeType="tmRoot">
           <p:childTnLst>
             <p:seq concurrent="1" nextAc="seek">
-              <p:cTn id="2" restart="whenNotActive" fill="hold" evtFilter="cancelBubble" nodeType="interactiveSeq">
+              <p:cTn id="2" dur="indefinite" nodeType="mainSeq">
+                <p:childTnLst>
+                  <p:par>
+                    <p:cTn id="3" fill="hold">
+                      <p:stCondLst>
+                        <p:cond delay="indefinite"/>
+                        <p:cond evt="onBegin" delay="0">
+                          <p:tn val="2"/>
+                        </p:cond>
+                      </p:stCondLst>
+                      <p:childTnLst>
+                        <p:par>
+                          <p:cTn id="4" fill="hold">
+                            <p:stCondLst>
+                              <p:cond delay="0"/>
+                            </p:stCondLst>
+                            <p:childTnLst>
+                              <p:par>
+                                <p:cTn id="5" presetID="1" presetClass="mediacall" presetSubtype="0" fill="hold" nodeType="afterEffect">
+                                  <p:stCondLst>
+                                    <p:cond delay="300"/>
+                                  </p:stCondLst>
+                                  <p:childTnLst>
+                                    <p:cmd type="call" cmd="playFrom(0.0)">
+                                      <p:cBhvr>
+                                        <p:cTn id="6" dur="967" fill="hold"/>
+                                        <p:tgtEl>
+                                          <p:spTgt spid="5"/>
+                                        </p:tgtEl>
+                                      </p:cBhvr>
+                                    </p:cmd>
+                                  </p:childTnLst>
+                                </p:cTn>
+                              </p:par>
+                            </p:childTnLst>
+                          </p:cTn>
+                        </p:par>
+                        <p:par>
+                          <p:cTn id="7" fill="hold">
+                            <p:stCondLst>
+                              <p:cond delay="1292"/>
+                            </p:stCondLst>
+                            <p:childTnLst>
+                              <p:par>
+                                <p:cTn id="8" presetID="1" presetClass="mediacall" presetSubtype="0" fill="hold" nodeType="afterEffect">
+                                  <p:stCondLst>
+                                    <p:cond delay="300"/>
+                                  </p:stCondLst>
+                                  <p:childTnLst>
+                                    <p:cmd type="call" cmd="playFrom(0.0)">
+                                      <p:cBhvr>
+                                        <p:cTn id="9" dur="967" fill="hold"/>
+                                        <p:tgtEl>
+                                          <p:spTgt spid="6"/>
+                                        </p:tgtEl>
+                                      </p:cBhvr>
+                                    </p:cmd>
+                                  </p:childTnLst>
+                                </p:cTn>
+                              </p:par>
+                            </p:childTnLst>
+                          </p:cTn>
+                        </p:par>
+                        <p:par>
+                          <p:cTn id="10" fill="hold">
+                            <p:stCondLst>
+                              <p:cond delay="2584"/>
+                            </p:stCondLst>
+                            <p:childTnLst>
+                              <p:par>
+                                <p:cTn id="11" presetID="1" presetClass="mediacall" presetSubtype="0" fill="hold" nodeType="afterEffect">
+                                  <p:stCondLst>
+                                    <p:cond delay="300"/>
+                                  </p:stCondLst>
+                                  <p:childTnLst>
+                                    <p:cmd type="call" cmd="playFrom(0.0)">
+                                      <p:cBhvr>
+                                        <p:cTn id="12" dur="3579" fill="hold"/>
+                                        <p:tgtEl>
+                                          <p:spTgt spid="11"/>
+                                        </p:tgtEl>
+                                      </p:cBhvr>
+                                    </p:cmd>
+                                  </p:childTnLst>
+                                </p:cTn>
+                              </p:par>
+                            </p:childTnLst>
+                          </p:cTn>
+                        </p:par>
+                      </p:childTnLst>
+                    </p:cTn>
+                  </p:par>
+                </p:childTnLst>
+              </p:cTn>
+              <p:prevCondLst>
+                <p:cond evt="onPrev" delay="0">
+                  <p:tgtEl>
+                    <p:sldTgt/>
+                  </p:tgtEl>
+                </p:cond>
+              </p:prevCondLst>
+              <p:nextCondLst>
+                <p:cond evt="onNext" delay="0">
+                  <p:tgtEl>
+                    <p:sldTgt/>
+                  </p:tgtEl>
+                </p:cond>
+              </p:nextCondLst>
+            </p:seq>
+            <p:seq concurrent="1" nextAc="seek">
+              <p:cTn id="13" restart="whenNotActive" fill="hold" evtFilter="cancelBubble" nodeType="interactiveSeq">
                 <p:stCondLst>
                   <p:cond evt="onClick" delay="0">
                     <p:tgtEl>
@@ -12110,26 +12962,26 @@
                 </p:endSync>
                 <p:childTnLst>
                   <p:par>
-                    <p:cTn id="3" fill="hold">
+                    <p:cTn id="14" fill="hold">
                       <p:stCondLst>
                         <p:cond delay="0"/>
                       </p:stCondLst>
                       <p:childTnLst>
                         <p:par>
-                          <p:cTn id="4" fill="hold">
+                          <p:cTn id="15" fill="hold">
                             <p:stCondLst>
                               <p:cond delay="0"/>
                             </p:stCondLst>
                             <p:childTnLst>
                               <p:par>
-                                <p:cTn id="5" presetID="1" presetClass="mediacall" presetSubtype="0" fill="hold" nodeType="clickEffect">
+                                <p:cTn id="16" presetID="1" presetClass="mediacall" presetSubtype="0" fill="hold" nodeType="clickEffect">
                                   <p:stCondLst>
                                     <p:cond delay="0"/>
                                   </p:stCondLst>
                                   <p:childTnLst>
                                     <p:cmd type="call" cmd="playFrom(0.0)">
                                       <p:cBhvr>
-                                        <p:cTn id="6" dur="992" fill="hold"/>
+                                        <p:cTn id="17" dur="992" fill="hold"/>
                                         <p:tgtEl>
                                           <p:spTgt spid="5"/>
                                         </p:tgtEl>
@@ -12156,7 +13008,7 @@
             </p:seq>
             <p:audio>
               <p:cMediaNode vol="80000">
-                <p:cTn id="7" fill="hold" display="0">
+                <p:cTn id="18" fill="hold" display="0">
                   <p:stCondLst>
                     <p:cond delay="indefinite"/>
                   </p:stCondLst>
@@ -12174,7 +13026,7 @@
               </p:cMediaNode>
             </p:audio>
             <p:seq concurrent="1" nextAc="seek">
-              <p:cTn id="8" restart="whenNotActive" fill="hold" evtFilter="cancelBubble" nodeType="interactiveSeq">
+              <p:cTn id="19" restart="whenNotActive" fill="hold" evtFilter="cancelBubble" nodeType="interactiveSeq">
                 <p:stCondLst>
                   <p:cond evt="onClick" delay="0">
                     <p:tgtEl>
@@ -12187,26 +13039,26 @@
                 </p:endSync>
                 <p:childTnLst>
                   <p:par>
-                    <p:cTn id="9" fill="hold">
+                    <p:cTn id="20" fill="hold">
                       <p:stCondLst>
                         <p:cond delay="0"/>
                       </p:stCondLst>
                       <p:childTnLst>
                         <p:par>
-                          <p:cTn id="10" fill="hold">
+                          <p:cTn id="21" fill="hold">
                             <p:stCondLst>
                               <p:cond delay="0"/>
                             </p:stCondLst>
                             <p:childTnLst>
                               <p:par>
-                                <p:cTn id="11" presetID="1" presetClass="mediacall" presetSubtype="0" fill="hold" nodeType="clickEffect">
+                                <p:cTn id="22" presetID="1" presetClass="mediacall" presetSubtype="0" fill="hold" nodeType="clickEffect">
                                   <p:stCondLst>
                                     <p:cond delay="0"/>
                                   </p:stCondLst>
                                   <p:childTnLst>
                                     <p:cmd type="call" cmd="playFrom(0.0)">
                                       <p:cBhvr>
-                                        <p:cTn id="12" dur="992" fill="hold"/>
+                                        <p:cTn id="23" dur="992" fill="hold"/>
                                         <p:tgtEl>
                                           <p:spTgt spid="6"/>
                                         </p:tgtEl>
@@ -12233,7 +13085,7 @@
             </p:seq>
             <p:audio>
               <p:cMediaNode vol="80000">
-                <p:cTn id="13" fill="hold" display="0">
+                <p:cTn id="24" fill="hold" display="0">
                   <p:stCondLst>
                     <p:cond delay="indefinite"/>
                   </p:stCondLst>
@@ -12251,7 +13103,7 @@
               </p:cMediaNode>
             </p:audio>
             <p:seq concurrent="1" nextAc="seek">
-              <p:cTn id="14" restart="whenNotActive" fill="hold" evtFilter="cancelBubble" nodeType="interactiveSeq">
+              <p:cTn id="25" restart="whenNotActive" fill="hold" evtFilter="cancelBubble" nodeType="interactiveSeq">
                 <p:stCondLst>
                   <p:cond evt="onClick" delay="0">
                     <p:tgtEl>
@@ -12264,26 +13116,26 @@
                 </p:endSync>
                 <p:childTnLst>
                   <p:par>
-                    <p:cTn id="15" fill="hold">
+                    <p:cTn id="26" fill="hold">
                       <p:stCondLst>
                         <p:cond delay="0"/>
                       </p:stCondLst>
                       <p:childTnLst>
                         <p:par>
-                          <p:cTn id="16" fill="hold">
+                          <p:cTn id="27" fill="hold">
                             <p:stCondLst>
                               <p:cond delay="0"/>
                             </p:stCondLst>
                             <p:childTnLst>
                               <p:par>
-                                <p:cTn id="17" presetID="1" presetClass="mediacall" presetSubtype="0" fill="hold" nodeType="clickEffect">
+                                <p:cTn id="28" presetID="1" presetClass="mediacall" presetSubtype="0" fill="hold" nodeType="clickEffect">
                                   <p:stCondLst>
                                     <p:cond delay="0"/>
                                   </p:stCondLst>
                                   <p:childTnLst>
                                     <p:cmd type="call" cmd="playFrom(0.0)">
                                       <p:cBhvr>
-                                        <p:cTn id="18" dur="3604" fill="hold"/>
+                                        <p:cTn id="29" dur="3604" fill="hold"/>
                                         <p:tgtEl>
                                           <p:spTgt spid="11"/>
                                         </p:tgtEl>
@@ -12310,7 +13162,7 @@
             </p:seq>
             <p:audio>
               <p:cMediaNode vol="80000">
-                <p:cTn id="19" fill="hold" display="0">
+                <p:cTn id="30" fill="hold" display="0">
                   <p:stCondLst>
                     <p:cond delay="indefinite"/>
                   </p:stCondLst>

</xml_diff>

<commit_message>
Implement audio embedding with timeline delays
</commit_message>
<xml_diff>
--- a/research/audio_full_test.pptx
+++ b/research/audio_full_test.pptx
@@ -3609,7 +3609,7 @@
             <a:hlinkClick r:id="" action="ppaction://media"/>
             <a:extLst>
               <a:ext uri="{FF2B5EF4-FFF2-40B4-BE49-F238E27FC236}">
-                <a16:creationId xmlns:a16="http://schemas.microsoft.com/office/drawing/2014/main" id="{DAAFA269-7762-3CA6-9E69-7893A55D32F7}"/>
+                <a16:creationId xmlns:a16="http://schemas.microsoft.com/office/drawing/2014/main" id="{B9A8C77B-E947-5696-DE2F-F9D9F7F6F627}"/>
               </a:ext>
             </a:extLst>
           </p:cNvPr>
@@ -3634,7 +3634,7 @@
         <p:spPr>
           <a:xfrm>
             <a:off x="0" y="0"/>
-            <a:ext cx="406400" cy="406400"/>
+            <a:ext cx="0" cy="0"/>
           </a:xfrm>
           <a:prstGeom prst="rect">
             <a:avLst/>
@@ -3647,7 +3647,7 @@
             <a:hlinkClick r:id="" action="ppaction://media"/>
             <a:extLst>
               <a:ext uri="{FF2B5EF4-FFF2-40B4-BE49-F238E27FC236}">
-                <a16:creationId xmlns:a16="http://schemas.microsoft.com/office/drawing/2014/main" id="{0F1F6335-756E-EAF2-2BBD-5FF3BE262B99}"/>
+                <a16:creationId xmlns:a16="http://schemas.microsoft.com/office/drawing/2014/main" id="{56DEB98A-B39E-78B3-E96B-ED1D8CD55D26}"/>
               </a:ext>
             </a:extLst>
           </p:cNvPr>
@@ -3672,7 +3672,7 @@
         <p:spPr>
           <a:xfrm>
             <a:off x="0" y="0"/>
-            <a:ext cx="406400" cy="406400"/>
+            <a:ext cx="0" cy="0"/>
           </a:xfrm>
           <a:prstGeom prst="rect">
             <a:avLst/>
@@ -3685,7 +3685,7 @@
             <a:hlinkClick r:id="" action="ppaction://media"/>
             <a:extLst>
               <a:ext uri="{FF2B5EF4-FFF2-40B4-BE49-F238E27FC236}">
-                <a16:creationId xmlns:a16="http://schemas.microsoft.com/office/drawing/2014/main" id="{14EFDA69-9BAF-E1EB-29DD-028643EE977C}"/>
+                <a16:creationId xmlns:a16="http://schemas.microsoft.com/office/drawing/2014/main" id="{079DDF23-04FE-AFE9-CBE1-C6FFBC64A67E}"/>
               </a:ext>
             </a:extLst>
           </p:cNvPr>
@@ -3710,7 +3710,7 @@
         <p:spPr>
           <a:xfrm>
             <a:off x="0" y="0"/>
-            <a:ext cx="406400" cy="406400"/>
+            <a:ext cx="0" cy="0"/>
           </a:xfrm>
           <a:prstGeom prst="rect">
             <a:avLst/>
@@ -3748,7 +3748,7 @@
                               <p:par>
                                 <p:cTn id="5" presetID="1" presetClass="mediacall" presetSubtype="0" fill="hold" nodeType="afterEffect">
                                   <p:stCondLst>
-                                    <p:cond delay="300"/>
+                                    <p:cond delay="500"/>
                                   </p:stCondLst>
                                   <p:childTnLst>
                                     <p:cmd type="call" cmd="playFrom(0.0)">
@@ -3768,7 +3768,7 @@
                         <p:par>
                           <p:cTn id="7" fill="hold">
                             <p:stCondLst>
-                              <p:cond delay="1240"/>
+                              <p:cond delay="1440"/>
                             </p:stCondLst>
                             <p:childTnLst>
                               <p:par>
@@ -3794,7 +3794,7 @@
                         <p:par>
                           <p:cTn id="10" fill="hold">
                             <p:stCondLst>
-                              <p:cond delay="2480"/>
+                              <p:cond delay="2680"/>
                             </p:stCondLst>
                             <p:childTnLst>
                               <p:par>
@@ -4606,7 +4606,7 @@
             <a:hlinkClick r:id="" action="ppaction://media"/>
             <a:extLst>
               <a:ext uri="{FF2B5EF4-FFF2-40B4-BE49-F238E27FC236}">
-                <a16:creationId xmlns:a16="http://schemas.microsoft.com/office/drawing/2014/main" id="{4D7FD7B9-7B69-2101-0B84-67FE66C7AC6E}"/>
+                <a16:creationId xmlns:a16="http://schemas.microsoft.com/office/drawing/2014/main" id="{A81072B2-EF61-6C63-5A68-8A7D1CADB280}"/>
               </a:ext>
             </a:extLst>
           </p:cNvPr>
@@ -4631,7 +4631,7 @@
         <p:spPr>
           <a:xfrm>
             <a:off x="0" y="0"/>
-            <a:ext cx="406400" cy="406400"/>
+            <a:ext cx="0" cy="0"/>
           </a:xfrm>
           <a:prstGeom prst="rect">
             <a:avLst/>
@@ -4669,7 +4669,7 @@
                               <p:par>
                                 <p:cTn id="5" presetID="1" presetClass="mediacall" presetSubtype="0" fill="hold" nodeType="afterEffect">
                                   <p:stCondLst>
-                                    <p:cond delay="300"/>
+                                    <p:cond delay="500"/>
                                   </p:stCondLst>
                                   <p:childTnLst>
                                     <p:cmd type="call" cmd="playFrom(0.0)">
@@ -5369,7 +5369,7 @@
             <a:hlinkClick r:id="" action="ppaction://media"/>
             <a:extLst>
               <a:ext uri="{FF2B5EF4-FFF2-40B4-BE49-F238E27FC236}">
-                <a16:creationId xmlns:a16="http://schemas.microsoft.com/office/drawing/2014/main" id="{CD0EB34D-2A46-5B75-684F-16DFB667A4F2}"/>
+                <a16:creationId xmlns:a16="http://schemas.microsoft.com/office/drawing/2014/main" id="{86B7A91C-FA56-F040-6F28-965C0A6AE46E}"/>
               </a:ext>
             </a:extLst>
           </p:cNvPr>
@@ -5394,7 +5394,7 @@
         <p:spPr>
           <a:xfrm>
             <a:off x="0" y="0"/>
-            <a:ext cx="406400" cy="406400"/>
+            <a:ext cx="0" cy="0"/>
           </a:xfrm>
           <a:prstGeom prst="rect">
             <a:avLst/>
@@ -5432,7 +5432,7 @@
                               <p:par>
                                 <p:cTn id="5" presetID="1" presetClass="mediacall" presetSubtype="0" fill="hold" nodeType="afterEffect">
                                   <p:stCondLst>
-                                    <p:cond delay="300"/>
+                                    <p:cond delay="500"/>
                                   </p:stCondLst>
                                   <p:childTnLst>
                                     <p:cmd type="call" cmd="playFrom(0.0)">
@@ -6180,7 +6180,7 @@
             <a:hlinkClick r:id="" action="ppaction://media"/>
             <a:extLst>
               <a:ext uri="{FF2B5EF4-FFF2-40B4-BE49-F238E27FC236}">
-                <a16:creationId xmlns:a16="http://schemas.microsoft.com/office/drawing/2014/main" id="{52EBFAEC-2F13-99B6-91B1-59F588BDE6FD}"/>
+                <a16:creationId xmlns:a16="http://schemas.microsoft.com/office/drawing/2014/main" id="{68A4B620-655E-69A2-613C-1624D48698AC}"/>
               </a:ext>
             </a:extLst>
           </p:cNvPr>
@@ -6205,7 +6205,7 @@
         <p:spPr>
           <a:xfrm>
             <a:off x="0" y="0"/>
-            <a:ext cx="406400" cy="406400"/>
+            <a:ext cx="0" cy="0"/>
           </a:xfrm>
           <a:prstGeom prst="rect">
             <a:avLst/>
@@ -6243,7 +6243,7 @@
                               <p:par>
                                 <p:cTn id="5" presetID="1" presetClass="mediacall" presetSubtype="0" fill="hold" nodeType="afterEffect">
                                   <p:stCondLst>
-                                    <p:cond delay="300"/>
+                                    <p:cond delay="500"/>
                                   </p:stCondLst>
                                   <p:childTnLst>
                                     <p:cmd type="call" cmd="playFrom(0.0)">
@@ -6972,7 +6972,7 @@
             <a:hlinkClick r:id="" action="ppaction://media"/>
             <a:extLst>
               <a:ext uri="{FF2B5EF4-FFF2-40B4-BE49-F238E27FC236}">
-                <a16:creationId xmlns:a16="http://schemas.microsoft.com/office/drawing/2014/main" id="{C5C84B64-3EB2-B304-F2D5-D15B52B1E6B5}"/>
+                <a16:creationId xmlns:a16="http://schemas.microsoft.com/office/drawing/2014/main" id="{033F2B9F-0ED8-9A52-F96B-FDAD97BA940C}"/>
               </a:ext>
             </a:extLst>
           </p:cNvPr>
@@ -6997,7 +6997,7 @@
         <p:spPr>
           <a:xfrm>
             <a:off x="0" y="0"/>
-            <a:ext cx="406400" cy="406400"/>
+            <a:ext cx="0" cy="0"/>
           </a:xfrm>
           <a:prstGeom prst="rect">
             <a:avLst/>
@@ -7040,7 +7040,7 @@
                               <p:par>
                                 <p:cTn id="5" presetID="1" presetClass="mediacall" presetSubtype="0" fill="hold" nodeType="afterEffect">
                                   <p:stCondLst>
-                                    <p:cond delay="300"/>
+                                    <p:cond delay="500"/>
                                   </p:stCondLst>
                                   <p:childTnLst>
                                     <p:cmd type="call" cmd="playFrom(0.0)">
@@ -7817,7 +7817,7 @@
             <a:hlinkClick r:id="" action="ppaction://media"/>
             <a:extLst>
               <a:ext uri="{FF2B5EF4-FFF2-40B4-BE49-F238E27FC236}">
-                <a16:creationId xmlns:a16="http://schemas.microsoft.com/office/drawing/2014/main" id="{150FEE74-BAF5-8962-C91A-FD74E3C1A95B}"/>
+                <a16:creationId xmlns:a16="http://schemas.microsoft.com/office/drawing/2014/main" id="{CE35295D-13DF-4EC5-170B-E682A49F0357}"/>
               </a:ext>
             </a:extLst>
           </p:cNvPr>
@@ -7842,7 +7842,7 @@
         <p:spPr>
           <a:xfrm>
             <a:off x="0" y="0"/>
-            <a:ext cx="406400" cy="406400"/>
+            <a:ext cx="0" cy="0"/>
           </a:xfrm>
           <a:prstGeom prst="rect">
             <a:avLst/>
@@ -7885,7 +7885,7 @@
                               <p:par>
                                 <p:cTn id="5" presetID="1" presetClass="mediacall" presetSubtype="0" fill="hold" nodeType="afterEffect">
                                   <p:stCondLst>
-                                    <p:cond delay="300"/>
+                                    <p:cond delay="500"/>
                                   </p:stCondLst>
                                   <p:childTnLst>
                                     <p:cmd type="call" cmd="playFrom(0.0)">
@@ -8710,7 +8710,7 @@
             <a:hlinkClick r:id="" action="ppaction://media"/>
             <a:extLst>
               <a:ext uri="{FF2B5EF4-FFF2-40B4-BE49-F238E27FC236}">
-                <a16:creationId xmlns:a16="http://schemas.microsoft.com/office/drawing/2014/main" id="{EF498C07-1311-1763-69E4-9063746CD2D4}"/>
+                <a16:creationId xmlns:a16="http://schemas.microsoft.com/office/drawing/2014/main" id="{E888AE9B-B405-C968-C1D2-54252920C7B7}"/>
               </a:ext>
             </a:extLst>
           </p:cNvPr>
@@ -8735,7 +8735,7 @@
         <p:spPr>
           <a:xfrm>
             <a:off x="0" y="0"/>
-            <a:ext cx="406400" cy="406400"/>
+            <a:ext cx="0" cy="0"/>
           </a:xfrm>
           <a:prstGeom prst="rect">
             <a:avLst/>
@@ -8778,7 +8778,7 @@
                               <p:par>
                                 <p:cTn id="5" presetID="1" presetClass="mediacall" presetSubtype="0" fill="hold" nodeType="afterEffect">
                                   <p:stCondLst>
-                                    <p:cond delay="300"/>
+                                    <p:cond delay="500"/>
                                   </p:stCondLst>
                                   <p:childTnLst>
                                     <p:cmd type="call" cmd="playFrom(0.0)">
@@ -9399,7 +9399,7 @@
             <a:hlinkClick r:id="" action="ppaction://media"/>
             <a:extLst>
               <a:ext uri="{FF2B5EF4-FFF2-40B4-BE49-F238E27FC236}">
-                <a16:creationId xmlns:a16="http://schemas.microsoft.com/office/drawing/2014/main" id="{68BB2564-9198-8CCF-EC83-C7DDCBFD73E0}"/>
+                <a16:creationId xmlns:a16="http://schemas.microsoft.com/office/drawing/2014/main" id="{5510444C-5E02-0143-D562-C1C35017B2B9}"/>
               </a:ext>
             </a:extLst>
           </p:cNvPr>
@@ -9424,7 +9424,7 @@
         <p:spPr>
           <a:xfrm>
             <a:off x="0" y="0"/>
-            <a:ext cx="406400" cy="406400"/>
+            <a:ext cx="0" cy="0"/>
           </a:xfrm>
           <a:prstGeom prst="rect">
             <a:avLst/>
@@ -9437,7 +9437,7 @@
             <a:hlinkClick r:id="" action="ppaction://media"/>
             <a:extLst>
               <a:ext uri="{FF2B5EF4-FFF2-40B4-BE49-F238E27FC236}">
-                <a16:creationId xmlns:a16="http://schemas.microsoft.com/office/drawing/2014/main" id="{D073356A-C47C-757E-E1E3-B70302FF5DD0}"/>
+                <a16:creationId xmlns:a16="http://schemas.microsoft.com/office/drawing/2014/main" id="{97D47B34-2A06-A5FD-0A7A-C97799665351}"/>
               </a:ext>
             </a:extLst>
           </p:cNvPr>
@@ -9462,7 +9462,7 @@
         <p:spPr>
           <a:xfrm>
             <a:off x="0" y="0"/>
-            <a:ext cx="406400" cy="406400"/>
+            <a:ext cx="0" cy="0"/>
           </a:xfrm>
           <a:prstGeom prst="rect">
             <a:avLst/>
@@ -9475,7 +9475,7 @@
             <a:hlinkClick r:id="" action="ppaction://media"/>
             <a:extLst>
               <a:ext uri="{FF2B5EF4-FFF2-40B4-BE49-F238E27FC236}">
-                <a16:creationId xmlns:a16="http://schemas.microsoft.com/office/drawing/2014/main" id="{219712B1-5ABA-4EC2-F390-DE4120E66197}"/>
+                <a16:creationId xmlns:a16="http://schemas.microsoft.com/office/drawing/2014/main" id="{48281BD3-743A-80BA-2E80-7323B3BE3D2B}"/>
               </a:ext>
             </a:extLst>
           </p:cNvPr>
@@ -9500,7 +9500,7 @@
         <p:spPr>
           <a:xfrm>
             <a:off x="0" y="0"/>
-            <a:ext cx="406400" cy="406400"/>
+            <a:ext cx="0" cy="0"/>
           </a:xfrm>
           <a:prstGeom prst="rect">
             <a:avLst/>
@@ -9538,7 +9538,7 @@
                               <p:par>
                                 <p:cTn id="5" presetID="1" presetClass="mediacall" presetSubtype="0" fill="hold" nodeType="afterEffect">
                                   <p:stCondLst>
-                                    <p:cond delay="300"/>
+                                    <p:cond delay="500"/>
                                   </p:stCondLst>
                                   <p:childTnLst>
                                     <p:cmd type="call" cmd="playFrom(0.0)">
@@ -9558,7 +9558,7 @@
                         <p:par>
                           <p:cTn id="7" fill="hold">
                             <p:stCondLst>
-                              <p:cond delay="1109"/>
+                              <p:cond delay="1309"/>
                             </p:stCondLst>
                             <p:childTnLst>
                               <p:par>
@@ -9584,7 +9584,7 @@
                         <p:par>
                           <p:cTn id="10" fill="hold">
                             <p:stCondLst>
-                              <p:cond delay="2218"/>
+                              <p:cond delay="2418"/>
                             </p:stCondLst>
                             <p:childTnLst>
                               <p:par>
@@ -10429,7 +10429,7 @@
             <a:hlinkClick r:id="" action="ppaction://media"/>
             <a:extLst>
               <a:ext uri="{FF2B5EF4-FFF2-40B4-BE49-F238E27FC236}">
-                <a16:creationId xmlns:a16="http://schemas.microsoft.com/office/drawing/2014/main" id="{5F74F083-73AC-F60B-25B4-4273CB88F453}"/>
+                <a16:creationId xmlns:a16="http://schemas.microsoft.com/office/drawing/2014/main" id="{282FF5E2-2BA7-0BA4-86A8-36A1B6EAD045}"/>
               </a:ext>
             </a:extLst>
           </p:cNvPr>
@@ -10454,7 +10454,7 @@
         <p:spPr>
           <a:xfrm>
             <a:off x="0" y="0"/>
-            <a:ext cx="406400" cy="406400"/>
+            <a:ext cx="0" cy="0"/>
           </a:xfrm>
           <a:prstGeom prst="rect">
             <a:avLst/>
@@ -10492,7 +10492,7 @@
                               <p:par>
                                 <p:cTn id="5" presetID="1" presetClass="mediacall" presetSubtype="0" fill="hold" nodeType="afterEffect">
                                   <p:stCondLst>
-                                    <p:cond delay="300"/>
+                                    <p:cond delay="500"/>
                                   </p:stCondLst>
                                   <p:childTnLst>
                                     <p:cmd type="call" cmd="playFrom(0.0)">
@@ -11225,7 +11225,7 @@
             <a:hlinkClick r:id="" action="ppaction://media"/>
             <a:extLst>
               <a:ext uri="{FF2B5EF4-FFF2-40B4-BE49-F238E27FC236}">
-                <a16:creationId xmlns:a16="http://schemas.microsoft.com/office/drawing/2014/main" id="{6C615693-84C1-9EF9-8045-0F6C9C0F3053}"/>
+                <a16:creationId xmlns:a16="http://schemas.microsoft.com/office/drawing/2014/main" id="{AEEC0D93-6728-FC92-1BE5-C09D89CDA505}"/>
               </a:ext>
             </a:extLst>
           </p:cNvPr>
@@ -11250,7 +11250,7 @@
         <p:spPr>
           <a:xfrm>
             <a:off x="0" y="0"/>
-            <a:ext cx="406400" cy="406400"/>
+            <a:ext cx="0" cy="0"/>
           </a:xfrm>
           <a:prstGeom prst="rect">
             <a:avLst/>
@@ -11288,7 +11288,7 @@
                               <p:par>
                                 <p:cTn id="5" presetID="1" presetClass="mediacall" presetSubtype="0" fill="hold" nodeType="afterEffect">
                                   <p:stCondLst>
-                                    <p:cond delay="300"/>
+                                    <p:cond delay="500"/>
                                   </p:stCondLst>
                                   <p:childTnLst>
                                     <p:cmd type="call" cmd="playFrom(0.0)">
@@ -12069,7 +12069,7 @@
             <a:hlinkClick r:id="" action="ppaction://media"/>
             <a:extLst>
               <a:ext uri="{FF2B5EF4-FFF2-40B4-BE49-F238E27FC236}">
-                <a16:creationId xmlns:a16="http://schemas.microsoft.com/office/drawing/2014/main" id="{A5DCA260-FEBC-FEE8-FE2F-182C11F2B188}"/>
+                <a16:creationId xmlns:a16="http://schemas.microsoft.com/office/drawing/2014/main" id="{94A92375-237A-D053-825B-02F81995C7DB}"/>
               </a:ext>
             </a:extLst>
           </p:cNvPr>
@@ -12094,7 +12094,7 @@
         <p:spPr>
           <a:xfrm>
             <a:off x="0" y="0"/>
-            <a:ext cx="406400" cy="406400"/>
+            <a:ext cx="0" cy="0"/>
           </a:xfrm>
           <a:prstGeom prst="rect">
             <a:avLst/>
@@ -12132,7 +12132,7 @@
                               <p:par>
                                 <p:cTn id="5" presetID="1" presetClass="mediacall" presetSubtype="0" fill="hold" nodeType="afterEffect">
                                   <p:stCondLst>
-                                    <p:cond delay="300"/>
+                                    <p:cond delay="500"/>
                                   </p:stCondLst>
                                   <p:childTnLst>
                                     <p:cmd type="call" cmd="playFrom(0.0)">
@@ -12720,7 +12720,7 @@
             <a:hlinkClick r:id="" action="ppaction://media"/>
             <a:extLst>
               <a:ext uri="{FF2B5EF4-FFF2-40B4-BE49-F238E27FC236}">
-                <a16:creationId xmlns:a16="http://schemas.microsoft.com/office/drawing/2014/main" id="{05B58CCF-A8CE-E433-B09C-D0902C2FFEDF}"/>
+                <a16:creationId xmlns:a16="http://schemas.microsoft.com/office/drawing/2014/main" id="{3FCAB454-F316-D910-DCAC-300A530A66C7}"/>
               </a:ext>
             </a:extLst>
           </p:cNvPr>
@@ -12745,7 +12745,7 @@
         <p:spPr>
           <a:xfrm>
             <a:off x="0" y="0"/>
-            <a:ext cx="406400" cy="406400"/>
+            <a:ext cx="0" cy="0"/>
           </a:xfrm>
           <a:prstGeom prst="rect">
             <a:avLst/>
@@ -12758,7 +12758,7 @@
             <a:hlinkClick r:id="" action="ppaction://media"/>
             <a:extLst>
               <a:ext uri="{FF2B5EF4-FFF2-40B4-BE49-F238E27FC236}">
-                <a16:creationId xmlns:a16="http://schemas.microsoft.com/office/drawing/2014/main" id="{E54587E5-FE53-7FE9-68BA-59E55B5B851F}"/>
+                <a16:creationId xmlns:a16="http://schemas.microsoft.com/office/drawing/2014/main" id="{62B3C5D4-C115-E63C-A9EE-98C2B156E5BA}"/>
               </a:ext>
             </a:extLst>
           </p:cNvPr>
@@ -12783,7 +12783,7 @@
         <p:spPr>
           <a:xfrm>
             <a:off x="0" y="0"/>
-            <a:ext cx="406400" cy="406400"/>
+            <a:ext cx="0" cy="0"/>
           </a:xfrm>
           <a:prstGeom prst="rect">
             <a:avLst/>
@@ -12796,7 +12796,7 @@
             <a:hlinkClick r:id="" action="ppaction://media"/>
             <a:extLst>
               <a:ext uri="{FF2B5EF4-FFF2-40B4-BE49-F238E27FC236}">
-                <a16:creationId xmlns:a16="http://schemas.microsoft.com/office/drawing/2014/main" id="{5537C46D-5F28-3ECE-E2B1-B99308DFFE86}"/>
+                <a16:creationId xmlns:a16="http://schemas.microsoft.com/office/drawing/2014/main" id="{9C23F561-7E23-208D-81A1-7E8A3F95EF75}"/>
               </a:ext>
             </a:extLst>
           </p:cNvPr>
@@ -12821,7 +12821,7 @@
         <p:spPr>
           <a:xfrm>
             <a:off x="0" y="0"/>
-            <a:ext cx="406400" cy="406400"/>
+            <a:ext cx="0" cy="0"/>
           </a:xfrm>
           <a:prstGeom prst="rect">
             <a:avLst/>
@@ -12859,7 +12859,7 @@
                               <p:par>
                                 <p:cTn id="5" presetID="1" presetClass="mediacall" presetSubtype="0" fill="hold" nodeType="afterEffect">
                                   <p:stCondLst>
-                                    <p:cond delay="300"/>
+                                    <p:cond delay="500"/>
                                   </p:stCondLst>
                                   <p:childTnLst>
                                     <p:cmd type="call" cmd="playFrom(0.0)">
@@ -12879,7 +12879,7 @@
                         <p:par>
                           <p:cTn id="7" fill="hold">
                             <p:stCondLst>
-                              <p:cond delay="1292"/>
+                              <p:cond delay="1492"/>
                             </p:stCondLst>
                             <p:childTnLst>
                               <p:par>
@@ -12905,7 +12905,7 @@
                         <p:par>
                           <p:cTn id="10" fill="hold">
                             <p:stCondLst>
-                              <p:cond delay="2584"/>
+                              <p:cond delay="2784"/>
                             </p:stCondLst>
                             <p:childTnLst>
                               <p:par>

</xml_diff>

<commit_message>
Add slide timeline and automatic slide timing
</commit_message>
<xml_diff>
--- a/research/audio_full_test.pptx
+++ b/research/audio_full_test.pptx
@@ -313,7 +313,7 @@
           <a:p>
             <a:fld id="{5BCAD085-E8A6-8845-BD4E-CB4CCA059FC4}" type="datetimeFigureOut">
               <a:rPr lang="en-US" smtClean="0"/>
-              <a:t>8/8/2026</a:t>
+              <a:t>8/9/2026</a:t>
             </a:fld>
             <a:endParaRPr lang="en-US"/>
           </a:p>
@@ -481,7 +481,7 @@
           <a:p>
             <a:fld id="{5BCAD085-E8A6-8845-BD4E-CB4CCA059FC4}" type="datetimeFigureOut">
               <a:rPr lang="en-US" smtClean="0"/>
-              <a:t>8/8/2026</a:t>
+              <a:t>8/9/2026</a:t>
             </a:fld>
             <a:endParaRPr lang="en-US"/>
           </a:p>
@@ -659,7 +659,7 @@
           <a:p>
             <a:fld id="{5BCAD085-E8A6-8845-BD4E-CB4CCA059FC4}" type="datetimeFigureOut">
               <a:rPr lang="en-US" smtClean="0"/>
-              <a:t>8/8/2026</a:t>
+              <a:t>8/9/2026</a:t>
             </a:fld>
             <a:endParaRPr lang="en-US"/>
           </a:p>
@@ -827,7 +827,7 @@
           <a:p>
             <a:fld id="{5BCAD085-E8A6-8845-BD4E-CB4CCA059FC4}" type="datetimeFigureOut">
               <a:rPr lang="en-US" smtClean="0"/>
-              <a:t>8/8/2026</a:t>
+              <a:t>8/9/2026</a:t>
             </a:fld>
             <a:endParaRPr lang="en-US"/>
           </a:p>
@@ -1072,7 +1072,7 @@
           <a:p>
             <a:fld id="{5BCAD085-E8A6-8845-BD4E-CB4CCA059FC4}" type="datetimeFigureOut">
               <a:rPr lang="en-US" smtClean="0"/>
-              <a:t>8/8/2026</a:t>
+              <a:t>8/9/2026</a:t>
             </a:fld>
             <a:endParaRPr lang="en-US"/>
           </a:p>
@@ -1357,7 +1357,7 @@
           <a:p>
             <a:fld id="{5BCAD085-E8A6-8845-BD4E-CB4CCA059FC4}" type="datetimeFigureOut">
               <a:rPr lang="en-US" smtClean="0"/>
-              <a:t>8/8/2026</a:t>
+              <a:t>8/9/2026</a:t>
             </a:fld>
             <a:endParaRPr lang="en-US"/>
           </a:p>
@@ -1776,7 +1776,7 @@
           <a:p>
             <a:fld id="{5BCAD085-E8A6-8845-BD4E-CB4CCA059FC4}" type="datetimeFigureOut">
               <a:rPr lang="en-US" smtClean="0"/>
-              <a:t>8/8/2026</a:t>
+              <a:t>8/9/2026</a:t>
             </a:fld>
             <a:endParaRPr lang="en-US"/>
           </a:p>
@@ -1893,7 +1893,7 @@
           <a:p>
             <a:fld id="{5BCAD085-E8A6-8845-BD4E-CB4CCA059FC4}" type="datetimeFigureOut">
               <a:rPr lang="en-US" smtClean="0"/>
-              <a:t>8/8/2026</a:t>
+              <a:t>8/9/2026</a:t>
             </a:fld>
             <a:endParaRPr lang="en-US"/>
           </a:p>
@@ -1988,7 +1988,7 @@
           <a:p>
             <a:fld id="{5BCAD085-E8A6-8845-BD4E-CB4CCA059FC4}" type="datetimeFigureOut">
               <a:rPr lang="en-US" smtClean="0"/>
-              <a:t>8/8/2026</a:t>
+              <a:t>8/9/2026</a:t>
             </a:fld>
             <a:endParaRPr lang="en-US"/>
           </a:p>
@@ -2263,7 +2263,7 @@
           <a:p>
             <a:fld id="{5BCAD085-E8A6-8845-BD4E-CB4CCA059FC4}" type="datetimeFigureOut">
               <a:rPr lang="en-US" smtClean="0"/>
-              <a:t>8/8/2026</a:t>
+              <a:t>8/9/2026</a:t>
             </a:fld>
             <a:endParaRPr lang="en-US"/>
           </a:p>
@@ -2515,7 +2515,7 @@
           <a:p>
             <a:fld id="{5BCAD085-E8A6-8845-BD4E-CB4CCA059FC4}" type="datetimeFigureOut">
               <a:rPr lang="en-US" smtClean="0"/>
-              <a:t>8/8/2026</a:t>
+              <a:t>8/9/2026</a:t>
             </a:fld>
             <a:endParaRPr lang="en-US"/>
           </a:p>
@@ -2726,7 +2726,7 @@
           <a:p>
             <a:fld id="{5BCAD085-E8A6-8845-BD4E-CB4CCA059FC4}" type="datetimeFigureOut">
               <a:rPr lang="en-US" smtClean="0"/>
-              <a:t>8/8/2026</a:t>
+              <a:t>8/9/2026</a:t>
             </a:fld>
             <a:endParaRPr lang="en-US"/>
           </a:p>
@@ -3609,7 +3609,7 @@
             <a:hlinkClick r:id="" action="ppaction://media"/>
             <a:extLst>
               <a:ext uri="{FF2B5EF4-FFF2-40B4-BE49-F238E27FC236}">
-                <a16:creationId xmlns:a16="http://schemas.microsoft.com/office/drawing/2014/main" id="{B9A8C77B-E947-5696-DE2F-F9D9F7F6F627}"/>
+                <a16:creationId xmlns:a16="http://schemas.microsoft.com/office/drawing/2014/main" id="{43B9DAE6-85E7-E486-7100-C2C75FC1B19B}"/>
               </a:ext>
             </a:extLst>
           </p:cNvPr>
@@ -3647,7 +3647,7 @@
             <a:hlinkClick r:id="" action="ppaction://media"/>
             <a:extLst>
               <a:ext uri="{FF2B5EF4-FFF2-40B4-BE49-F238E27FC236}">
-                <a16:creationId xmlns:a16="http://schemas.microsoft.com/office/drawing/2014/main" id="{56DEB98A-B39E-78B3-E96B-ED1D8CD55D26}"/>
+                <a16:creationId xmlns:a16="http://schemas.microsoft.com/office/drawing/2014/main" id="{7219D4CB-5B30-7778-E5BD-E013D086CAA2}"/>
               </a:ext>
             </a:extLst>
           </p:cNvPr>
@@ -3685,7 +3685,7 @@
             <a:hlinkClick r:id="" action="ppaction://media"/>
             <a:extLst>
               <a:ext uri="{FF2B5EF4-FFF2-40B4-BE49-F238E27FC236}">
-                <a16:creationId xmlns:a16="http://schemas.microsoft.com/office/drawing/2014/main" id="{079DDF23-04FE-AFE9-CBE1-C6FFBC64A67E}"/>
+                <a16:creationId xmlns:a16="http://schemas.microsoft.com/office/drawing/2014/main" id="{DE9F4255-38C6-CE38-0FA1-5867DDBE34A4}"/>
               </a:ext>
             </a:extLst>
           </p:cNvPr>
@@ -3722,6 +3722,14 @@
   <p:clrMapOvr>
     <a:masterClrMapping/>
   </p:clrMapOvr>
+  <mc:AlternateContent xmlns:mc="http://schemas.openxmlformats.org/markup-compatibility/2006">
+    <mc:Choice xmlns:p14="http://schemas.microsoft.com/office/powerpoint/2010/main" Requires="p14">
+      <p:transition spd="slow" p14:dur="2000" advTm="6403"/>
+    </mc:Choice>
+    <mc:Fallback>
+      <p:transition spd="slow" advTm="6403"/>
+    </mc:Fallback>
+  </mc:AlternateContent>
   <p:timing>
     <p:tnLst>
       <p:par>
@@ -4606,7 +4614,7 @@
             <a:hlinkClick r:id="" action="ppaction://media"/>
             <a:extLst>
               <a:ext uri="{FF2B5EF4-FFF2-40B4-BE49-F238E27FC236}">
-                <a16:creationId xmlns:a16="http://schemas.microsoft.com/office/drawing/2014/main" id="{A81072B2-EF61-6C63-5A68-8A7D1CADB280}"/>
+                <a16:creationId xmlns:a16="http://schemas.microsoft.com/office/drawing/2014/main" id="{8B6DC16A-2910-CB68-53AA-AD7A7665BF37}"/>
               </a:ext>
             </a:extLst>
           </p:cNvPr>
@@ -4643,6 +4651,14 @@
   <p:clrMapOvr>
     <a:masterClrMapping/>
   </p:clrMapOvr>
+  <mc:AlternateContent xmlns:mc="http://schemas.openxmlformats.org/markup-compatibility/2006">
+    <mc:Choice xmlns:p14="http://schemas.microsoft.com/office/powerpoint/2010/main" Requires="p14">
+      <p:transition spd="slow" p14:dur="2000" advTm="4862"/>
+    </mc:Choice>
+    <mc:Fallback>
+      <p:transition spd="slow" advTm="4862"/>
+    </mc:Fallback>
+  </mc:AlternateContent>
   <p:timing>
     <p:tnLst>
       <p:par>
@@ -5369,7 +5385,7 @@
             <a:hlinkClick r:id="" action="ppaction://media"/>
             <a:extLst>
               <a:ext uri="{FF2B5EF4-FFF2-40B4-BE49-F238E27FC236}">
-                <a16:creationId xmlns:a16="http://schemas.microsoft.com/office/drawing/2014/main" id="{86B7A91C-FA56-F040-6F28-965C0A6AE46E}"/>
+                <a16:creationId xmlns:a16="http://schemas.microsoft.com/office/drawing/2014/main" id="{FFE4C721-242C-7889-EE08-323A29A0803B}"/>
               </a:ext>
             </a:extLst>
           </p:cNvPr>
@@ -5406,6 +5422,14 @@
   <p:clrMapOvr>
     <a:masterClrMapping/>
   </p:clrMapOvr>
+  <mc:AlternateContent xmlns:mc="http://schemas.openxmlformats.org/markup-compatibility/2006">
+    <mc:Choice xmlns:p14="http://schemas.microsoft.com/office/powerpoint/2010/main" Requires="p14">
+      <p:transition spd="slow" p14:dur="2000" advTm="5124"/>
+    </mc:Choice>
+    <mc:Fallback>
+      <p:transition spd="slow" advTm="5124"/>
+    </mc:Fallback>
+  </mc:AlternateContent>
   <p:timing>
     <p:tnLst>
       <p:par>
@@ -6180,7 +6204,7 @@
             <a:hlinkClick r:id="" action="ppaction://media"/>
             <a:extLst>
               <a:ext uri="{FF2B5EF4-FFF2-40B4-BE49-F238E27FC236}">
-                <a16:creationId xmlns:a16="http://schemas.microsoft.com/office/drawing/2014/main" id="{68A4B620-655E-69A2-613C-1624D48698AC}"/>
+                <a16:creationId xmlns:a16="http://schemas.microsoft.com/office/drawing/2014/main" id="{7BD80140-57F4-F134-7CAC-592892C7BEB9}"/>
               </a:ext>
             </a:extLst>
           </p:cNvPr>
@@ -6217,6 +6241,14 @@
   <p:clrMapOvr>
     <a:masterClrMapping/>
   </p:clrMapOvr>
+  <mc:AlternateContent xmlns:mc="http://schemas.openxmlformats.org/markup-compatibility/2006">
+    <mc:Choice xmlns:p14="http://schemas.microsoft.com/office/powerpoint/2010/main" Requires="p14">
+      <p:transition spd="slow" p14:dur="2000" advTm="4993"/>
+    </mc:Choice>
+    <mc:Fallback>
+      <p:transition spd="slow" advTm="4993"/>
+    </mc:Fallback>
+  </mc:AlternateContent>
   <p:timing>
     <p:tnLst>
       <p:par>
@@ -6972,7 +7004,7 @@
             <a:hlinkClick r:id="" action="ppaction://media"/>
             <a:extLst>
               <a:ext uri="{FF2B5EF4-FFF2-40B4-BE49-F238E27FC236}">
-                <a16:creationId xmlns:a16="http://schemas.microsoft.com/office/drawing/2014/main" id="{033F2B9F-0ED8-9A52-F96B-FDAD97BA940C}"/>
+                <a16:creationId xmlns:a16="http://schemas.microsoft.com/office/drawing/2014/main" id="{17290C73-F6C1-36B2-081F-C816C330E612}"/>
               </a:ext>
             </a:extLst>
           </p:cNvPr>
@@ -7014,6 +7046,14 @@
   <p:clrMapOvr>
     <a:masterClrMapping/>
   </p:clrMapOvr>
+  <mc:AlternateContent xmlns:mc="http://schemas.openxmlformats.org/markup-compatibility/2006">
+    <mc:Choice xmlns:p14="http://schemas.microsoft.com/office/powerpoint/2010/main" Requires="p14">
+      <p:transition spd="slow" p14:dur="2000" advTm="5463"/>
+    </mc:Choice>
+    <mc:Fallback>
+      <p:transition spd="slow" advTm="5463"/>
+    </mc:Fallback>
+  </mc:AlternateContent>
   <p:timing>
     <p:tnLst>
       <p:par>
@@ -7817,7 +7857,7 @@
             <a:hlinkClick r:id="" action="ppaction://media"/>
             <a:extLst>
               <a:ext uri="{FF2B5EF4-FFF2-40B4-BE49-F238E27FC236}">
-                <a16:creationId xmlns:a16="http://schemas.microsoft.com/office/drawing/2014/main" id="{CE35295D-13DF-4EC5-170B-E682A49F0357}"/>
+                <a16:creationId xmlns:a16="http://schemas.microsoft.com/office/drawing/2014/main" id="{A0315ED8-D9AE-65A9-2CCC-72516C09338F}"/>
               </a:ext>
             </a:extLst>
           </p:cNvPr>
@@ -7859,6 +7899,14 @@
   <p:clrMapOvr>
     <a:masterClrMapping/>
   </p:clrMapOvr>
+  <mc:AlternateContent xmlns:mc="http://schemas.openxmlformats.org/markup-compatibility/2006">
+    <mc:Choice xmlns:p14="http://schemas.microsoft.com/office/powerpoint/2010/main" Requires="p14">
+      <p:transition spd="slow" p14:dur="2000" advTm="5359"/>
+    </mc:Choice>
+    <mc:Fallback>
+      <p:transition spd="slow" advTm="5359"/>
+    </mc:Fallback>
+  </mc:AlternateContent>
   <p:timing>
     <p:tnLst>
       <p:par>
@@ -8710,7 +8758,7 @@
             <a:hlinkClick r:id="" action="ppaction://media"/>
             <a:extLst>
               <a:ext uri="{FF2B5EF4-FFF2-40B4-BE49-F238E27FC236}">
-                <a16:creationId xmlns:a16="http://schemas.microsoft.com/office/drawing/2014/main" id="{E888AE9B-B405-C968-C1D2-54252920C7B7}"/>
+                <a16:creationId xmlns:a16="http://schemas.microsoft.com/office/drawing/2014/main" id="{DB6B50D1-4CD8-F235-8221-3E72EE8D4839}"/>
               </a:ext>
             </a:extLst>
           </p:cNvPr>
@@ -8752,6 +8800,14 @@
   <p:clrMapOvr>
     <a:masterClrMapping/>
   </p:clrMapOvr>
+  <mc:AlternateContent xmlns:mc="http://schemas.openxmlformats.org/markup-compatibility/2006">
+    <mc:Choice xmlns:p14="http://schemas.microsoft.com/office/powerpoint/2010/main" Requires="p14">
+      <p:transition spd="slow" p14:dur="2000" advTm="5333"/>
+    </mc:Choice>
+    <mc:Fallback>
+      <p:transition spd="slow" advTm="5333"/>
+    </mc:Fallback>
+  </mc:AlternateContent>
   <p:timing>
     <p:tnLst>
       <p:par>
@@ -9399,7 +9455,7 @@
             <a:hlinkClick r:id="" action="ppaction://media"/>
             <a:extLst>
               <a:ext uri="{FF2B5EF4-FFF2-40B4-BE49-F238E27FC236}">
-                <a16:creationId xmlns:a16="http://schemas.microsoft.com/office/drawing/2014/main" id="{5510444C-5E02-0143-D562-C1C35017B2B9}"/>
+                <a16:creationId xmlns:a16="http://schemas.microsoft.com/office/drawing/2014/main" id="{0925C968-A881-98EC-00AB-9CD4BB408C68}"/>
               </a:ext>
             </a:extLst>
           </p:cNvPr>
@@ -9437,7 +9493,7 @@
             <a:hlinkClick r:id="" action="ppaction://media"/>
             <a:extLst>
               <a:ext uri="{FF2B5EF4-FFF2-40B4-BE49-F238E27FC236}">
-                <a16:creationId xmlns:a16="http://schemas.microsoft.com/office/drawing/2014/main" id="{97D47B34-2A06-A5FD-0A7A-C97799665351}"/>
+                <a16:creationId xmlns:a16="http://schemas.microsoft.com/office/drawing/2014/main" id="{605D9A48-ACE5-27B5-AB86-BABAE26E38B2}"/>
               </a:ext>
             </a:extLst>
           </p:cNvPr>
@@ -9475,7 +9531,7 @@
             <a:hlinkClick r:id="" action="ppaction://media"/>
             <a:extLst>
               <a:ext uri="{FF2B5EF4-FFF2-40B4-BE49-F238E27FC236}">
-                <a16:creationId xmlns:a16="http://schemas.microsoft.com/office/drawing/2014/main" id="{48281BD3-743A-80BA-2E80-7323B3BE3D2B}"/>
+                <a16:creationId xmlns:a16="http://schemas.microsoft.com/office/drawing/2014/main" id="{D2AAE9B5-8F34-D465-CEB1-C97A29628ED9}"/>
               </a:ext>
             </a:extLst>
           </p:cNvPr>
@@ -9512,6 +9568,14 @@
   <p:clrMapOvr>
     <a:masterClrMapping/>
   </p:clrMapOvr>
+  <mc:AlternateContent xmlns:mc="http://schemas.openxmlformats.org/markup-compatibility/2006">
+    <mc:Choice xmlns:p14="http://schemas.microsoft.com/office/powerpoint/2010/main" Requires="p14">
+      <p:transition spd="slow" p14:dur="2000" advTm="5071"/>
+    </mc:Choice>
+    <mc:Fallback>
+      <p:transition spd="slow" advTm="5071"/>
+    </mc:Fallback>
+  </mc:AlternateContent>
   <p:timing>
     <p:tnLst>
       <p:par>
@@ -10429,7 +10493,7 @@
             <a:hlinkClick r:id="" action="ppaction://media"/>
             <a:extLst>
               <a:ext uri="{FF2B5EF4-FFF2-40B4-BE49-F238E27FC236}">
-                <a16:creationId xmlns:a16="http://schemas.microsoft.com/office/drawing/2014/main" id="{282FF5E2-2BA7-0BA4-86A8-36A1B6EAD045}"/>
+                <a16:creationId xmlns:a16="http://schemas.microsoft.com/office/drawing/2014/main" id="{234D8A2A-1300-6738-F008-4463242DE6D5}"/>
               </a:ext>
             </a:extLst>
           </p:cNvPr>
@@ -10466,6 +10530,14 @@
   <p:clrMapOvr>
     <a:masterClrMapping/>
   </p:clrMapOvr>
+  <mc:AlternateContent xmlns:mc="http://schemas.openxmlformats.org/markup-compatibility/2006">
+    <mc:Choice xmlns:p14="http://schemas.microsoft.com/office/powerpoint/2010/main" Requires="p14">
+      <p:transition spd="slow" p14:dur="2000" advTm="4862"/>
+    </mc:Choice>
+    <mc:Fallback>
+      <p:transition spd="slow" advTm="4862"/>
+    </mc:Fallback>
+  </mc:AlternateContent>
   <p:timing>
     <p:tnLst>
       <p:par>
@@ -11225,7 +11297,7 @@
             <a:hlinkClick r:id="" action="ppaction://media"/>
             <a:extLst>
               <a:ext uri="{FF2B5EF4-FFF2-40B4-BE49-F238E27FC236}">
-                <a16:creationId xmlns:a16="http://schemas.microsoft.com/office/drawing/2014/main" id="{AEEC0D93-6728-FC92-1BE5-C09D89CDA505}"/>
+                <a16:creationId xmlns:a16="http://schemas.microsoft.com/office/drawing/2014/main" id="{BF4AEED8-F2BD-8F4D-30D9-5501FE511A1B}"/>
               </a:ext>
             </a:extLst>
           </p:cNvPr>
@@ -11262,6 +11334,14 @@
   <p:clrMapOvr>
     <a:masterClrMapping/>
   </p:clrMapOvr>
+  <mc:AlternateContent xmlns:mc="http://schemas.openxmlformats.org/markup-compatibility/2006">
+    <mc:Choice xmlns:p14="http://schemas.microsoft.com/office/powerpoint/2010/main" Requires="p14">
+      <p:transition spd="slow" p14:dur="2000" advTm="4575"/>
+    </mc:Choice>
+    <mc:Fallback>
+      <p:transition spd="slow" advTm="4575"/>
+    </mc:Fallback>
+  </mc:AlternateContent>
   <p:timing>
     <p:tnLst>
       <p:par>
@@ -12069,7 +12149,7 @@
             <a:hlinkClick r:id="" action="ppaction://media"/>
             <a:extLst>
               <a:ext uri="{FF2B5EF4-FFF2-40B4-BE49-F238E27FC236}">
-                <a16:creationId xmlns:a16="http://schemas.microsoft.com/office/drawing/2014/main" id="{94A92375-237A-D053-825B-02F81995C7DB}"/>
+                <a16:creationId xmlns:a16="http://schemas.microsoft.com/office/drawing/2014/main" id="{8EC4CE91-4637-40DE-3E38-2F2E64955E9E}"/>
               </a:ext>
             </a:extLst>
           </p:cNvPr>
@@ -12106,6 +12186,14 @@
   <p:clrMapOvr>
     <a:masterClrMapping/>
   </p:clrMapOvr>
+  <mc:AlternateContent xmlns:mc="http://schemas.openxmlformats.org/markup-compatibility/2006">
+    <mc:Choice xmlns:p14="http://schemas.microsoft.com/office/powerpoint/2010/main" Requires="p14">
+      <p:transition spd="slow" p14:dur="2000" advTm="5228"/>
+    </mc:Choice>
+    <mc:Fallback>
+      <p:transition spd="slow" advTm="5228"/>
+    </mc:Fallback>
+  </mc:AlternateContent>
   <p:timing>
     <p:tnLst>
       <p:par>
@@ -12720,7 +12808,7 @@
             <a:hlinkClick r:id="" action="ppaction://media"/>
             <a:extLst>
               <a:ext uri="{FF2B5EF4-FFF2-40B4-BE49-F238E27FC236}">
-                <a16:creationId xmlns:a16="http://schemas.microsoft.com/office/drawing/2014/main" id="{3FCAB454-F316-D910-DCAC-300A530A66C7}"/>
+                <a16:creationId xmlns:a16="http://schemas.microsoft.com/office/drawing/2014/main" id="{D8100998-EF2B-E9B0-3761-E4917CE88AD0}"/>
               </a:ext>
             </a:extLst>
           </p:cNvPr>
@@ -12758,7 +12846,7 @@
             <a:hlinkClick r:id="" action="ppaction://media"/>
             <a:extLst>
               <a:ext uri="{FF2B5EF4-FFF2-40B4-BE49-F238E27FC236}">
-                <a16:creationId xmlns:a16="http://schemas.microsoft.com/office/drawing/2014/main" id="{62B3C5D4-C115-E63C-A9EE-98C2B156E5BA}"/>
+                <a16:creationId xmlns:a16="http://schemas.microsoft.com/office/drawing/2014/main" id="{2EEBB067-2F48-D94A-5401-185D7102BCDC}"/>
               </a:ext>
             </a:extLst>
           </p:cNvPr>
@@ -12796,7 +12884,7 @@
             <a:hlinkClick r:id="" action="ppaction://media"/>
             <a:extLst>
               <a:ext uri="{FF2B5EF4-FFF2-40B4-BE49-F238E27FC236}">
-                <a16:creationId xmlns:a16="http://schemas.microsoft.com/office/drawing/2014/main" id="{9C23F561-7E23-208D-81A1-7E8A3F95EF75}"/>
+                <a16:creationId xmlns:a16="http://schemas.microsoft.com/office/drawing/2014/main" id="{1FD2420A-DD56-FD7A-A132-6AFE1754649C}"/>
               </a:ext>
             </a:extLst>
           </p:cNvPr>
@@ -12833,6 +12921,14 @@
   <p:clrMapOvr>
     <a:masterClrMapping/>
   </p:clrMapOvr>
+  <mc:AlternateContent xmlns:mc="http://schemas.openxmlformats.org/markup-compatibility/2006">
+    <mc:Choice xmlns:p14="http://schemas.microsoft.com/office/powerpoint/2010/main" Requires="p14">
+      <p:transition spd="slow" p14:dur="2000" advTm="6612"/>
+    </mc:Choice>
+    <mc:Fallback>
+      <p:transition spd="slow" advTm="6612"/>
+    </mc:Fallback>
+  </mc:AlternateContent>
   <p:timing>
     <p:tnLst>
       <p:par>

</xml_diff>

<commit_message>
Basic MVP version completed
</commit_message>
<xml_diff>
--- a/research/audio_full_test.pptx
+++ b/research/audio_full_test.pptx
@@ -313,7 +313,7 @@
           <a:p>
             <a:fld id="{5BCAD085-E8A6-8845-BD4E-CB4CCA059FC4}" type="datetimeFigureOut">
               <a:rPr lang="en-US" smtClean="0"/>
-              <a:t>8/9/2026</a:t>
+              <a:t>8/10/2026</a:t>
             </a:fld>
             <a:endParaRPr lang="en-US"/>
           </a:p>
@@ -481,7 +481,7 @@
           <a:p>
             <a:fld id="{5BCAD085-E8A6-8845-BD4E-CB4CCA059FC4}" type="datetimeFigureOut">
               <a:rPr lang="en-US" smtClean="0"/>
-              <a:t>8/9/2026</a:t>
+              <a:t>8/10/2026</a:t>
             </a:fld>
             <a:endParaRPr lang="en-US"/>
           </a:p>
@@ -659,7 +659,7 @@
           <a:p>
             <a:fld id="{5BCAD085-E8A6-8845-BD4E-CB4CCA059FC4}" type="datetimeFigureOut">
               <a:rPr lang="en-US" smtClean="0"/>
-              <a:t>8/9/2026</a:t>
+              <a:t>8/10/2026</a:t>
             </a:fld>
             <a:endParaRPr lang="en-US"/>
           </a:p>
@@ -827,7 +827,7 @@
           <a:p>
             <a:fld id="{5BCAD085-E8A6-8845-BD4E-CB4CCA059FC4}" type="datetimeFigureOut">
               <a:rPr lang="en-US" smtClean="0"/>
-              <a:t>8/9/2026</a:t>
+              <a:t>8/10/2026</a:t>
             </a:fld>
             <a:endParaRPr lang="en-US"/>
           </a:p>
@@ -1072,7 +1072,7 @@
           <a:p>
             <a:fld id="{5BCAD085-E8A6-8845-BD4E-CB4CCA059FC4}" type="datetimeFigureOut">
               <a:rPr lang="en-US" smtClean="0"/>
-              <a:t>8/9/2026</a:t>
+              <a:t>8/10/2026</a:t>
             </a:fld>
             <a:endParaRPr lang="en-US"/>
           </a:p>
@@ -1357,7 +1357,7 @@
           <a:p>
             <a:fld id="{5BCAD085-E8A6-8845-BD4E-CB4CCA059FC4}" type="datetimeFigureOut">
               <a:rPr lang="en-US" smtClean="0"/>
-              <a:t>8/9/2026</a:t>
+              <a:t>8/10/2026</a:t>
             </a:fld>
             <a:endParaRPr lang="en-US"/>
           </a:p>
@@ -1776,7 +1776,7 @@
           <a:p>
             <a:fld id="{5BCAD085-E8A6-8845-BD4E-CB4CCA059FC4}" type="datetimeFigureOut">
               <a:rPr lang="en-US" smtClean="0"/>
-              <a:t>8/9/2026</a:t>
+              <a:t>8/10/2026</a:t>
             </a:fld>
             <a:endParaRPr lang="en-US"/>
           </a:p>
@@ -1893,7 +1893,7 @@
           <a:p>
             <a:fld id="{5BCAD085-E8A6-8845-BD4E-CB4CCA059FC4}" type="datetimeFigureOut">
               <a:rPr lang="en-US" smtClean="0"/>
-              <a:t>8/9/2026</a:t>
+              <a:t>8/10/2026</a:t>
             </a:fld>
             <a:endParaRPr lang="en-US"/>
           </a:p>
@@ -1988,7 +1988,7 @@
           <a:p>
             <a:fld id="{5BCAD085-E8A6-8845-BD4E-CB4CCA059FC4}" type="datetimeFigureOut">
               <a:rPr lang="en-US" smtClean="0"/>
-              <a:t>8/9/2026</a:t>
+              <a:t>8/10/2026</a:t>
             </a:fld>
             <a:endParaRPr lang="en-US"/>
           </a:p>
@@ -2263,7 +2263,7 @@
           <a:p>
             <a:fld id="{5BCAD085-E8A6-8845-BD4E-CB4CCA059FC4}" type="datetimeFigureOut">
               <a:rPr lang="en-US" smtClean="0"/>
-              <a:t>8/9/2026</a:t>
+              <a:t>8/10/2026</a:t>
             </a:fld>
             <a:endParaRPr lang="en-US"/>
           </a:p>
@@ -2515,7 +2515,7 @@
           <a:p>
             <a:fld id="{5BCAD085-E8A6-8845-BD4E-CB4CCA059FC4}" type="datetimeFigureOut">
               <a:rPr lang="en-US" smtClean="0"/>
-              <a:t>8/9/2026</a:t>
+              <a:t>8/10/2026</a:t>
             </a:fld>
             <a:endParaRPr lang="en-US"/>
           </a:p>
@@ -2726,7 +2726,7 @@
           <a:p>
             <a:fld id="{5BCAD085-E8A6-8845-BD4E-CB4CCA059FC4}" type="datetimeFigureOut">
               <a:rPr lang="en-US" smtClean="0"/>
-              <a:t>8/9/2026</a:t>
+              <a:t>8/10/2026</a:t>
             </a:fld>
             <a:endParaRPr lang="en-US"/>
           </a:p>
@@ -3609,7 +3609,7 @@
             <a:hlinkClick r:id="" action="ppaction://media"/>
             <a:extLst>
               <a:ext uri="{FF2B5EF4-FFF2-40B4-BE49-F238E27FC236}">
-                <a16:creationId xmlns:a16="http://schemas.microsoft.com/office/drawing/2014/main" id="{43B9DAE6-85E7-E486-7100-C2C75FC1B19B}"/>
+                <a16:creationId xmlns:a16="http://schemas.microsoft.com/office/drawing/2014/main" id="{782CA993-305B-7853-8B55-5428E4AF54E2}"/>
               </a:ext>
             </a:extLst>
           </p:cNvPr>
@@ -3647,7 +3647,7 @@
             <a:hlinkClick r:id="" action="ppaction://media"/>
             <a:extLst>
               <a:ext uri="{FF2B5EF4-FFF2-40B4-BE49-F238E27FC236}">
-                <a16:creationId xmlns:a16="http://schemas.microsoft.com/office/drawing/2014/main" id="{7219D4CB-5B30-7778-E5BD-E013D086CAA2}"/>
+                <a16:creationId xmlns:a16="http://schemas.microsoft.com/office/drawing/2014/main" id="{656B8D39-1408-5F35-AC3A-F0404DF16503}"/>
               </a:ext>
             </a:extLst>
           </p:cNvPr>
@@ -3685,7 +3685,7 @@
             <a:hlinkClick r:id="" action="ppaction://media"/>
             <a:extLst>
               <a:ext uri="{FF2B5EF4-FFF2-40B4-BE49-F238E27FC236}">
-                <a16:creationId xmlns:a16="http://schemas.microsoft.com/office/drawing/2014/main" id="{DE9F4255-38C6-CE38-0FA1-5867DDBE34A4}"/>
+                <a16:creationId xmlns:a16="http://schemas.microsoft.com/office/drawing/2014/main" id="{5585BFC2-F3E8-A493-B6B2-1B21CFB17F94}"/>
               </a:ext>
             </a:extLst>
           </p:cNvPr>
@@ -4614,7 +4614,7 @@
             <a:hlinkClick r:id="" action="ppaction://media"/>
             <a:extLst>
               <a:ext uri="{FF2B5EF4-FFF2-40B4-BE49-F238E27FC236}">
-                <a16:creationId xmlns:a16="http://schemas.microsoft.com/office/drawing/2014/main" id="{8B6DC16A-2910-CB68-53AA-AD7A7665BF37}"/>
+                <a16:creationId xmlns:a16="http://schemas.microsoft.com/office/drawing/2014/main" id="{EC8A05C5-912B-F763-DD7F-7F38601C399C}"/>
               </a:ext>
             </a:extLst>
           </p:cNvPr>
@@ -5385,7 +5385,7 @@
             <a:hlinkClick r:id="" action="ppaction://media"/>
             <a:extLst>
               <a:ext uri="{FF2B5EF4-FFF2-40B4-BE49-F238E27FC236}">
-                <a16:creationId xmlns:a16="http://schemas.microsoft.com/office/drawing/2014/main" id="{FFE4C721-242C-7889-EE08-323A29A0803B}"/>
+                <a16:creationId xmlns:a16="http://schemas.microsoft.com/office/drawing/2014/main" id="{FE4F5607-050E-868B-2AA9-AF140418E2D3}"/>
               </a:ext>
             </a:extLst>
           </p:cNvPr>
@@ -6204,7 +6204,7 @@
             <a:hlinkClick r:id="" action="ppaction://media"/>
             <a:extLst>
               <a:ext uri="{FF2B5EF4-FFF2-40B4-BE49-F238E27FC236}">
-                <a16:creationId xmlns:a16="http://schemas.microsoft.com/office/drawing/2014/main" id="{7BD80140-57F4-F134-7CAC-592892C7BEB9}"/>
+                <a16:creationId xmlns:a16="http://schemas.microsoft.com/office/drawing/2014/main" id="{7EAC3878-0CC8-88E0-1801-FD28F591907D}"/>
               </a:ext>
             </a:extLst>
           </p:cNvPr>
@@ -7004,7 +7004,7 @@
             <a:hlinkClick r:id="" action="ppaction://media"/>
             <a:extLst>
               <a:ext uri="{FF2B5EF4-FFF2-40B4-BE49-F238E27FC236}">
-                <a16:creationId xmlns:a16="http://schemas.microsoft.com/office/drawing/2014/main" id="{17290C73-F6C1-36B2-081F-C816C330E612}"/>
+                <a16:creationId xmlns:a16="http://schemas.microsoft.com/office/drawing/2014/main" id="{8ED45E62-84A3-532C-7FF0-EF8CA117FDA0}"/>
               </a:ext>
             </a:extLst>
           </p:cNvPr>
@@ -7857,7 +7857,7 @@
             <a:hlinkClick r:id="" action="ppaction://media"/>
             <a:extLst>
               <a:ext uri="{FF2B5EF4-FFF2-40B4-BE49-F238E27FC236}">
-                <a16:creationId xmlns:a16="http://schemas.microsoft.com/office/drawing/2014/main" id="{A0315ED8-D9AE-65A9-2CCC-72516C09338F}"/>
+                <a16:creationId xmlns:a16="http://schemas.microsoft.com/office/drawing/2014/main" id="{AACAA18E-AA50-56F9-1ED7-B7B6323E2445}"/>
               </a:ext>
             </a:extLst>
           </p:cNvPr>
@@ -8758,7 +8758,7 @@
             <a:hlinkClick r:id="" action="ppaction://media"/>
             <a:extLst>
               <a:ext uri="{FF2B5EF4-FFF2-40B4-BE49-F238E27FC236}">
-                <a16:creationId xmlns:a16="http://schemas.microsoft.com/office/drawing/2014/main" id="{DB6B50D1-4CD8-F235-8221-3E72EE8D4839}"/>
+                <a16:creationId xmlns:a16="http://schemas.microsoft.com/office/drawing/2014/main" id="{BF809B14-A25D-762D-2551-96D03076BBDB}"/>
               </a:ext>
             </a:extLst>
           </p:cNvPr>
@@ -9455,7 +9455,7 @@
             <a:hlinkClick r:id="" action="ppaction://media"/>
             <a:extLst>
               <a:ext uri="{FF2B5EF4-FFF2-40B4-BE49-F238E27FC236}">
-                <a16:creationId xmlns:a16="http://schemas.microsoft.com/office/drawing/2014/main" id="{0925C968-A881-98EC-00AB-9CD4BB408C68}"/>
+                <a16:creationId xmlns:a16="http://schemas.microsoft.com/office/drawing/2014/main" id="{92FA74A0-2B49-F5E2-A18A-C7C73B52ABE0}"/>
               </a:ext>
             </a:extLst>
           </p:cNvPr>
@@ -9493,7 +9493,7 @@
             <a:hlinkClick r:id="" action="ppaction://media"/>
             <a:extLst>
               <a:ext uri="{FF2B5EF4-FFF2-40B4-BE49-F238E27FC236}">
-                <a16:creationId xmlns:a16="http://schemas.microsoft.com/office/drawing/2014/main" id="{605D9A48-ACE5-27B5-AB86-BABAE26E38B2}"/>
+                <a16:creationId xmlns:a16="http://schemas.microsoft.com/office/drawing/2014/main" id="{EFCE0A68-8291-73E2-4351-5E9BECE03C05}"/>
               </a:ext>
             </a:extLst>
           </p:cNvPr>
@@ -9531,7 +9531,7 @@
             <a:hlinkClick r:id="" action="ppaction://media"/>
             <a:extLst>
               <a:ext uri="{FF2B5EF4-FFF2-40B4-BE49-F238E27FC236}">
-                <a16:creationId xmlns:a16="http://schemas.microsoft.com/office/drawing/2014/main" id="{D2AAE9B5-8F34-D465-CEB1-C97A29628ED9}"/>
+                <a16:creationId xmlns:a16="http://schemas.microsoft.com/office/drawing/2014/main" id="{14DA74C9-3EAB-7B7A-AAEB-8EB3B97A718D}"/>
               </a:ext>
             </a:extLst>
           </p:cNvPr>
@@ -10493,7 +10493,7 @@
             <a:hlinkClick r:id="" action="ppaction://media"/>
             <a:extLst>
               <a:ext uri="{FF2B5EF4-FFF2-40B4-BE49-F238E27FC236}">
-                <a16:creationId xmlns:a16="http://schemas.microsoft.com/office/drawing/2014/main" id="{234D8A2A-1300-6738-F008-4463242DE6D5}"/>
+                <a16:creationId xmlns:a16="http://schemas.microsoft.com/office/drawing/2014/main" id="{166FF59C-AC90-D14C-D21F-DC1AAC9937D5}"/>
               </a:ext>
             </a:extLst>
           </p:cNvPr>
@@ -11297,7 +11297,7 @@
             <a:hlinkClick r:id="" action="ppaction://media"/>
             <a:extLst>
               <a:ext uri="{FF2B5EF4-FFF2-40B4-BE49-F238E27FC236}">
-                <a16:creationId xmlns:a16="http://schemas.microsoft.com/office/drawing/2014/main" id="{BF4AEED8-F2BD-8F4D-30D9-5501FE511A1B}"/>
+                <a16:creationId xmlns:a16="http://schemas.microsoft.com/office/drawing/2014/main" id="{06044AE1-BD85-B2A7-FDD5-CCF6FE0C0C76}"/>
               </a:ext>
             </a:extLst>
           </p:cNvPr>
@@ -12149,7 +12149,7 @@
             <a:hlinkClick r:id="" action="ppaction://media"/>
             <a:extLst>
               <a:ext uri="{FF2B5EF4-FFF2-40B4-BE49-F238E27FC236}">
-                <a16:creationId xmlns:a16="http://schemas.microsoft.com/office/drawing/2014/main" id="{8EC4CE91-4637-40DE-3E38-2F2E64955E9E}"/>
+                <a16:creationId xmlns:a16="http://schemas.microsoft.com/office/drawing/2014/main" id="{FD5758D0-AA5C-5432-2AA5-26DDEF717BF5}"/>
               </a:ext>
             </a:extLst>
           </p:cNvPr>
@@ -12808,7 +12808,7 @@
             <a:hlinkClick r:id="" action="ppaction://media"/>
             <a:extLst>
               <a:ext uri="{FF2B5EF4-FFF2-40B4-BE49-F238E27FC236}">
-                <a16:creationId xmlns:a16="http://schemas.microsoft.com/office/drawing/2014/main" id="{D8100998-EF2B-E9B0-3761-E4917CE88AD0}"/>
+                <a16:creationId xmlns:a16="http://schemas.microsoft.com/office/drawing/2014/main" id="{33F1651B-DF08-7FDF-C722-AC575F504740}"/>
               </a:ext>
             </a:extLst>
           </p:cNvPr>
@@ -12846,7 +12846,7 @@
             <a:hlinkClick r:id="" action="ppaction://media"/>
             <a:extLst>
               <a:ext uri="{FF2B5EF4-FFF2-40B4-BE49-F238E27FC236}">
-                <a16:creationId xmlns:a16="http://schemas.microsoft.com/office/drawing/2014/main" id="{2EEBB067-2F48-D94A-5401-185D7102BCDC}"/>
+                <a16:creationId xmlns:a16="http://schemas.microsoft.com/office/drawing/2014/main" id="{C56F45ED-2917-8018-CA5F-BBC4A76D7DF9}"/>
               </a:ext>
             </a:extLst>
           </p:cNvPr>
@@ -12884,7 +12884,7 @@
             <a:hlinkClick r:id="" action="ppaction://media"/>
             <a:extLst>
               <a:ext uri="{FF2B5EF4-FFF2-40B4-BE49-F238E27FC236}">
-                <a16:creationId xmlns:a16="http://schemas.microsoft.com/office/drawing/2014/main" id="{1FD2420A-DD56-FD7A-A132-6AFE1754649C}"/>
+                <a16:creationId xmlns:a16="http://schemas.microsoft.com/office/drawing/2014/main" id="{2F99EA45-1BA4-7683-7AAE-C6931E2BAA61}"/>
               </a:ext>
             </a:extLst>
           </p:cNvPr>

</xml_diff>